<commit_message>
Add DC-08 action commitment page to 15-page boss-mode deck
Co-Authored-By: Claude Fable 5 <noreply@anthropic.com>
</commit_message>
<xml_diff>
--- a/domains/yuhong/outputs/县域机会诊断_看趋势与判状态_老板版_V0.1.pptx
+++ b/domains/yuhong/outputs/县域机会诊断_看趋势与判状态_老板版_V0.1.pptx
@@ -5,23 +5,24 @@
     <p:sldMasterId id="2147483648" r:id="rId1"/>
   </p:sldMasterIdLst>
   <p:notesMasterIdLst>
-    <p:notesMasterId r:id="rId16"/>
+    <p:notesMasterId r:id="rId17"/>
   </p:notesMasterIdLst>
   <p:sldIdLst>
-    <p:sldId id="267" r:id="rId2"/>
-    <p:sldId id="266" r:id="rId3"/>
-    <p:sldId id="265" r:id="rId4"/>
-    <p:sldId id="264" r:id="rId5"/>
-    <p:sldId id="263" r:id="rId6"/>
-    <p:sldId id="262" r:id="rId7"/>
+    <p:sldId id="268" r:id="rId2"/>
+    <p:sldId id="267" r:id="rId3"/>
+    <p:sldId id="266" r:id="rId4"/>
+    <p:sldId id="265" r:id="rId5"/>
+    <p:sldId id="264" r:id="rId6"/>
+    <p:sldId id="263" r:id="rId7"/>
     <p:sldId id="256" r:id="rId8"/>
     <p:sldId id="257" r:id="rId9"/>
     <p:sldId id="258" r:id="rId10"/>
     <p:sldId id="259" r:id="rId11"/>
     <p:sldId id="260" r:id="rId12"/>
     <p:sldId id="261" r:id="rId13"/>
-    <p:sldId id="268" r:id="rId14"/>
+    <p:sldId id="262" r:id="rId14"/>
     <p:sldId id="269" r:id="rId15"/>
+    <p:sldId id="270" r:id="rId16"/>
   </p:sldIdLst>
   <p:sldSz cx="12192000" cy="6858000"/>
   <p:notesSz cx="6858000" cy="9144000"/>
@@ -440,7 +441,7 @@
     </p:spTree>
     <p:extLst>
       <p:ext uri="{BB962C8B-B14F-4D97-AF65-F5344CB8AC3E}">
-        <p14:creationId xmlns:p14="http://schemas.microsoft.com/office/powerpoint/2010/main" val="2090387507"/>
+        <p14:creationId xmlns:p14="http://schemas.microsoft.com/office/powerpoint/2010/main" val="1876093891"/>
       </p:ext>
     </p:extLst>
   </p:cSld>
@@ -796,7 +797,35 @@
                 <a:latin typeface="Microsoft YaHei" panose="020B0503020204020204" pitchFamily="34" charset="-122"/>
                 <a:ea typeface="Microsoft YaHei" panose="020B0503020204020204" pitchFamily="34" charset="-122"/>
               </a:rPr>
-              <a:t>示例只用来讲「怎么填」，不是标准答案；每个老板的版图要由真实经营信息构成，课后与县长共同补充。说明作业与下一模块的关系：判状态看「我现在做到哪一步」，盘区域看「哪些地方外部机会更大」。</a:t>
+              <a:t>行动板是课程收尾的动作承诺页：老板从前面诊断出的短板</a:t>
+            </a:r>
+            <a:r>
+              <a:rPr lang="en-US" altLang="zh-CN" sz="1100">
+                <a:latin typeface="Microsoft YaHei" panose="020B0503020204020204" pitchFamily="34" charset="-122"/>
+                <a:ea typeface="Microsoft YaHei" panose="020B0503020204020204" pitchFamily="34" charset="-122"/>
+              </a:rPr>
+              <a:t>/</a:t>
+            </a:r>
+            <a:r>
+              <a:rPr lang="zh-CN" altLang="en-US" sz="1100">
+                <a:latin typeface="Microsoft YaHei" panose="020B0503020204020204" pitchFamily="34" charset="-122"/>
+                <a:ea typeface="Microsoft YaHei" panose="020B0503020204020204" pitchFamily="34" charset="-122"/>
+              </a:rPr>
+              <a:t>机会反推动作，不凭空列待办。每项行动必须能检查（对象、动作、责任人、节点、指标）。最多 </a:t>
+            </a:r>
+            <a:r>
+              <a:rPr lang="en-US" altLang="zh-CN" sz="1100">
+                <a:latin typeface="Microsoft YaHei" panose="020B0503020204020204" pitchFamily="34" charset="-122"/>
+                <a:ea typeface="Microsoft YaHei" panose="020B0503020204020204" pitchFamily="34" charset="-122"/>
+              </a:rPr>
+              <a:t>3 </a:t>
+            </a:r>
+            <a:r>
+              <a:rPr lang="zh-CN" altLang="en-US" sz="1100">
+                <a:latin typeface="Microsoft YaHei" panose="020B0503020204020204" pitchFamily="34" charset="-122"/>
+                <a:ea typeface="Microsoft YaHei" panose="020B0503020204020204" pitchFamily="34" charset="-122"/>
+              </a:rPr>
+              <a:t>项最重要的，优先动作从短板反推，禁止从病症直接跳到多铺货多压货。</a:t>
             </a:r>
           </a:p>
         </p:txBody>
@@ -823,7 +852,7 @@
     </p:spTree>
     <p:extLst>
       <p:ext uri="{BB962C8B-B14F-4D97-AF65-F5344CB8AC3E}">
-        <p14:creationId xmlns:p14="http://schemas.microsoft.com/office/powerpoint/2010/main" val="1865681681"/>
+        <p14:creationId xmlns:p14="http://schemas.microsoft.com/office/powerpoint/2010/main" val="817954929"/>
       </p:ext>
     </p:extLst>
   </p:cSld>
@@ -882,21 +911,7 @@
                 <a:latin typeface="Microsoft YaHei" panose="020B0503020204020204" pitchFamily="34" charset="-122"/>
                 <a:ea typeface="Microsoft YaHei" panose="020B0503020204020204" pitchFamily="34" charset="-122"/>
               </a:rPr>
-              <a:t>结尾不追加新内容，只给一个明确动作。如果老板问「那到底投哪」：答案不在今天这页材料里，在盘区域这一步</a:t>
-            </a:r>
-            <a:r>
-              <a:rPr lang="en-US" altLang="zh-CN" sz="1100">
-                <a:latin typeface="Microsoft YaHei" panose="020B0503020204020204" pitchFamily="34" charset="-122"/>
-                <a:ea typeface="Microsoft YaHei" panose="020B0503020204020204" pitchFamily="34" charset="-122"/>
-              </a:rPr>
-              <a:t>——</a:t>
-            </a:r>
-            <a:r>
-              <a:rPr lang="zh-CN" altLang="en-US" sz="1100">
-                <a:latin typeface="Microsoft YaHei" panose="020B0503020204020204" pitchFamily="34" charset="-122"/>
-                <a:ea typeface="Microsoft YaHei" panose="020B0503020204020204" pitchFamily="34" charset="-122"/>
-              </a:rPr>
-              <a:t>把版图带上会，我们用它排出优先级。</a:t>
+              <a:t>示例只用来讲「怎么填」，不是标准答案；每个老板的版图要由真实经营信息构成，课后与县长共同补充。说明作业与下一模块的关系：判状态看「我现在做到哪一步」，盘区域看「哪些地方外部机会更大」。</a:t>
             </a:r>
           </a:p>
         </p:txBody>
@@ -923,7 +938,107 @@
     </p:spTree>
     <p:extLst>
       <p:ext uri="{BB962C8B-B14F-4D97-AF65-F5344CB8AC3E}">
-        <p14:creationId xmlns:p14="http://schemas.microsoft.com/office/powerpoint/2010/main" val="3240918498"/>
+        <p14:creationId xmlns:p14="http://schemas.microsoft.com/office/powerpoint/2010/main" val="3380912492"/>
+      </p:ext>
+    </p:extLst>
+  </p:cSld>
+  <p:clrMapOvr>
+    <a:masterClrMapping/>
+  </p:clrMapOvr>
+</p:notes>
+</file>
+
+<file path=ppt/notesSlides/notesSlide15.xml><?xml version="1.0" encoding="utf-8"?>
+<p:notes xmlns:a="http://schemas.openxmlformats.org/drawingml/2006/main" xmlns:r="http://schemas.openxmlformats.org/officeDocument/2006/relationships" xmlns:p="http://schemas.openxmlformats.org/presentationml/2006/main">
+  <p:cSld>
+    <p:spTree>
+      <p:nvGrpSpPr>
+        <p:cNvPr id="1" name=""/>
+        <p:cNvGrpSpPr/>
+        <p:nvPr/>
+      </p:nvGrpSpPr>
+      <p:grpSpPr>
+        <a:xfrm>
+          <a:off x="0" y="0"/>
+          <a:ext cx="0" cy="0"/>
+          <a:chOff x="0" y="0"/>
+          <a:chExt cx="0" cy="0"/>
+        </a:xfrm>
+      </p:grpSpPr>
+      <p:sp>
+        <p:nvSpPr>
+          <p:cNvPr id="2" name="幻灯片图像占位符 1"/>
+          <p:cNvSpPr>
+            <a:spLocks noGrp="1" noRot="1" noChangeAspect="1"/>
+          </p:cNvSpPr>
+          <p:nvPr>
+            <p:ph type="sldImg"/>
+          </p:nvPr>
+        </p:nvSpPr>
+        <p:spPr/>
+      </p:sp>
+      <p:sp>
+        <p:nvSpPr>
+          <p:cNvPr id="3" name="备注占位符 2"/>
+          <p:cNvSpPr>
+            <a:spLocks noGrp="1"/>
+          </p:cNvSpPr>
+          <p:nvPr>
+            <p:ph type="body" idx="1"/>
+          </p:nvPr>
+        </p:nvSpPr>
+        <p:spPr/>
+        <p:txBody>
+          <a:bodyPr/>
+          <a:lstStyle/>
+          <a:p>
+            <a:r>
+              <a:rPr lang="zh-CN" altLang="en-US" sz="1100">
+                <a:latin typeface="Microsoft YaHei" panose="020B0503020204020204" pitchFamily="34" charset="-122"/>
+                <a:ea typeface="Microsoft YaHei" panose="020B0503020204020204" pitchFamily="34" charset="-122"/>
+              </a:rPr>
+              <a:t>结尾不追加新内容，只给一个明确动作。如果老板问「那到底投哪」：答案不在今天这页材料里，在盘区域这一步</a:t>
+            </a:r>
+            <a:r>
+              <a:rPr lang="en-US" altLang="zh-CN" sz="1100">
+                <a:latin typeface="Microsoft YaHei" panose="020B0503020204020204" pitchFamily="34" charset="-122"/>
+                <a:ea typeface="Microsoft YaHei" panose="020B0503020204020204" pitchFamily="34" charset="-122"/>
+              </a:rPr>
+              <a:t>——</a:t>
+            </a:r>
+            <a:r>
+              <a:rPr lang="zh-CN" altLang="en-US" sz="1100">
+                <a:latin typeface="Microsoft YaHei" panose="020B0503020204020204" pitchFamily="34" charset="-122"/>
+                <a:ea typeface="Microsoft YaHei" panose="020B0503020204020204" pitchFamily="34" charset="-122"/>
+              </a:rPr>
+              <a:t>把版图带上会，我们用它排出优先级。</a:t>
+            </a:r>
+          </a:p>
+        </p:txBody>
+      </p:sp>
+      <p:sp>
+        <p:nvSpPr>
+          <p:cNvPr id="4" name="灯片编号占位符 3"/>
+          <p:cNvSpPr>
+            <a:spLocks noGrp="1"/>
+          </p:cNvSpPr>
+          <p:nvPr>
+            <p:ph type="sldNum" sz="quarter" idx="5"/>
+          </p:nvPr>
+        </p:nvSpPr>
+        <p:spPr/>
+        <p:txBody>
+          <a:bodyPr/>
+          <a:lstStyle/>
+          <a:p>
+            <a:endParaRPr lang="zh-CN" altLang="en-US"/>
+          </a:p>
+        </p:txBody>
+      </p:sp>
+    </p:spTree>
+    <p:extLst>
+      <p:ext uri="{BB962C8B-B14F-4D97-AF65-F5344CB8AC3E}">
+        <p14:creationId xmlns:p14="http://schemas.microsoft.com/office/powerpoint/2010/main" val="4018450015"/>
       </p:ext>
     </p:extLst>
   </p:cSld>
@@ -1023,7 +1138,7 @@
     </p:spTree>
     <p:extLst>
       <p:ext uri="{BB962C8B-B14F-4D97-AF65-F5344CB8AC3E}">
-        <p14:creationId xmlns:p14="http://schemas.microsoft.com/office/powerpoint/2010/main" val="783609630"/>
+        <p14:creationId xmlns:p14="http://schemas.microsoft.com/office/powerpoint/2010/main" val="3804335293"/>
       </p:ext>
     </p:extLst>
   </p:cSld>
@@ -1151,7 +1266,7 @@
     </p:spTree>
     <p:extLst>
       <p:ext uri="{BB962C8B-B14F-4D97-AF65-F5344CB8AC3E}">
-        <p14:creationId xmlns:p14="http://schemas.microsoft.com/office/powerpoint/2010/main" val="1912797602"/>
+        <p14:creationId xmlns:p14="http://schemas.microsoft.com/office/powerpoint/2010/main" val="3373242581"/>
       </p:ext>
     </p:extLst>
   </p:cSld>
@@ -1237,7 +1352,7 @@
     </p:spTree>
     <p:extLst>
       <p:ext uri="{BB962C8B-B14F-4D97-AF65-F5344CB8AC3E}">
-        <p14:creationId xmlns:p14="http://schemas.microsoft.com/office/powerpoint/2010/main" val="3824406150"/>
+        <p14:creationId xmlns:p14="http://schemas.microsoft.com/office/powerpoint/2010/main" val="2799587002"/>
       </p:ext>
     </p:extLst>
   </p:cSld>
@@ -1323,7 +1438,7 @@
     </p:spTree>
     <p:extLst>
       <p:ext uri="{BB962C8B-B14F-4D97-AF65-F5344CB8AC3E}">
-        <p14:creationId xmlns:p14="http://schemas.microsoft.com/office/powerpoint/2010/main" val="4156942680"/>
+        <p14:creationId xmlns:p14="http://schemas.microsoft.com/office/powerpoint/2010/main" val="3508762530"/>
       </p:ext>
     </p:extLst>
   </p:cSld>
@@ -1479,7 +1594,7 @@
     </p:spTree>
     <p:extLst>
       <p:ext uri="{BB962C8B-B14F-4D97-AF65-F5344CB8AC3E}">
-        <p14:creationId xmlns:p14="http://schemas.microsoft.com/office/powerpoint/2010/main" val="4138483645"/>
+        <p14:creationId xmlns:p14="http://schemas.microsoft.com/office/powerpoint/2010/main" val="1868194"/>
       </p:ext>
     </p:extLst>
   </p:cSld>
@@ -2216,7 +2331,7 @@
           <p:cNvPr id="2" name="文本框 1">
             <a:extLst>
               <a:ext uri="{FF2B5EF4-FFF2-40B4-BE49-F238E27FC236}">
-                <a16:creationId xmlns:a16="http://schemas.microsoft.com/office/drawing/2014/main" id="{DE768606-A628-A140-86CE-907ECDCF41B1}"/>
+                <a16:creationId xmlns:a16="http://schemas.microsoft.com/office/drawing/2014/main" id="{0E41A16D-8190-B17C-05D8-43336C92BF57}"/>
               </a:ext>
             </a:extLst>
           </p:cNvPr>
@@ -2278,7 +2393,7 @@
           <p:cNvPr id="3" name="文本框 2">
             <a:extLst>
               <a:ext uri="{FF2B5EF4-FFF2-40B4-BE49-F238E27FC236}">
-                <a16:creationId xmlns:a16="http://schemas.microsoft.com/office/drawing/2014/main" id="{17AC18E7-5E76-F3FB-1240-B21B58C410C0}"/>
+                <a16:creationId xmlns:a16="http://schemas.microsoft.com/office/drawing/2014/main" id="{C1E7B524-9609-1955-666F-D18EFAF82763}"/>
               </a:ext>
             </a:extLst>
           </p:cNvPr>
@@ -2320,7 +2435,7 @@
           <p:cNvPr id="4" name="文本框 3">
             <a:extLst>
               <a:ext uri="{FF2B5EF4-FFF2-40B4-BE49-F238E27FC236}">
-                <a16:creationId xmlns:a16="http://schemas.microsoft.com/office/drawing/2014/main" id="{1A15C043-67CE-770C-37A1-2D0A7D65C2E7}"/>
+                <a16:creationId xmlns:a16="http://schemas.microsoft.com/office/drawing/2014/main" id="{893AFB62-D5AC-C567-9871-F4C8D002AF83}"/>
               </a:ext>
             </a:extLst>
           </p:cNvPr>
@@ -2382,7 +2497,7 @@
           <p:cNvPr id="5" name="文本框 4">
             <a:extLst>
               <a:ext uri="{FF2B5EF4-FFF2-40B4-BE49-F238E27FC236}">
-                <a16:creationId xmlns:a16="http://schemas.microsoft.com/office/drawing/2014/main" id="{E1F3D211-DAF6-E7A1-597A-B95510634DD9}"/>
+                <a16:creationId xmlns:a16="http://schemas.microsoft.com/office/drawing/2014/main" id="{B802A448-8402-D574-9DE6-2B727207ED3A}"/>
               </a:ext>
             </a:extLst>
           </p:cNvPr>
@@ -2442,7 +2557,7 @@
     </p:spTree>
     <p:extLst>
       <p:ext uri="{BB962C8B-B14F-4D97-AF65-F5344CB8AC3E}">
-        <p14:creationId xmlns:p14="http://schemas.microsoft.com/office/powerpoint/2010/main" val="40661227"/>
+        <p14:creationId xmlns:p14="http://schemas.microsoft.com/office/powerpoint/2010/main" val="3797984486"/>
       </p:ext>
     </p:extLst>
   </p:cSld>
@@ -7979,10 +8094,10 @@
       </p:grpSpPr>
       <p:sp>
         <p:nvSpPr>
-          <p:cNvPr id="2" name="文本框 1">
-            <a:extLst>
-              <a:ext uri="{FF2B5EF4-FFF2-40B4-BE49-F238E27FC236}">
-                <a16:creationId xmlns:a16="http://schemas.microsoft.com/office/drawing/2014/main" id="{60CE2CED-7FC3-1079-50BA-4B3D4E2B8954}"/>
+          <p:cNvPr id="2" name="TITLE">
+            <a:extLst>
+              <a:ext uri="{FF2B5EF4-FFF2-40B4-BE49-F238E27FC236}">
+                <a16:creationId xmlns:a16="http://schemas.microsoft.com/office/drawing/2014/main" id="{88D97873-1814-2820-21C8-C16459AB8C5F}"/>
               </a:ext>
             </a:extLst>
           </p:cNvPr>
@@ -7992,7 +8107,7 @@
         <p:spPr>
           <a:xfrm>
             <a:off x="548640" y="384048"/>
-            <a:ext cx="11064240" cy="369332"/>
+            <a:ext cx="10607040" cy="825500"/>
           </a:xfrm>
           <a:prstGeom prst="rect">
             <a:avLst/>
@@ -8013,17 +8128,37 @@
                 <a:latin typeface="Microsoft YaHei" panose="020B0503020204020204" pitchFamily="34" charset="-122"/>
                 <a:ea typeface="Microsoft YaHei" panose="020B0503020204020204" pitchFamily="34" charset="-122"/>
               </a:rPr>
-              <a:t>课后作业：画出你的县域生意版图</a:t>
-            </a:r>
-          </a:p>
-        </p:txBody>
-      </p:sp>
-      <p:sp>
-        <p:nvSpPr>
-          <p:cNvPr id="3" name="文本框 2">
-            <a:extLst>
-              <a:ext uri="{FF2B5EF4-FFF2-40B4-BE49-F238E27FC236}">
-                <a16:creationId xmlns:a16="http://schemas.microsoft.com/office/drawing/2014/main" id="{28AD85E3-ABA8-E175-6CAD-07BBE4A8F59D}"/>
+              <a:t>未来 </a:t>
+            </a:r>
+            <a:r>
+              <a:rPr lang="en-US" altLang="zh-CN" sz="2600" b="1">
+                <a:solidFill>
+                  <a:srgbClr val="172A3A"/>
+                </a:solidFill>
+                <a:latin typeface="Microsoft YaHei" panose="020B0503020204020204" pitchFamily="34" charset="-122"/>
+                <a:ea typeface="Microsoft YaHei" panose="020B0503020204020204" pitchFamily="34" charset="-122"/>
+              </a:rPr>
+              <a:t>30 </a:t>
+            </a:r>
+            <a:r>
+              <a:rPr lang="zh-CN" altLang="en-US" sz="2600" b="1">
+                <a:solidFill>
+                  <a:srgbClr val="172A3A"/>
+                </a:solidFill>
+                <a:latin typeface="Microsoft YaHei" panose="020B0503020204020204" pitchFamily="34" charset="-122"/>
+                <a:ea typeface="Microsoft YaHei" panose="020B0503020204020204" pitchFamily="34" charset="-122"/>
+              </a:rPr>
+              <a:t>天行动承诺</a:t>
+            </a:r>
+          </a:p>
+        </p:txBody>
+      </p:sp>
+      <p:sp>
+        <p:nvSpPr>
+          <p:cNvPr id="3" name="SUBTITLE">
+            <a:extLst>
+              <a:ext uri="{FF2B5EF4-FFF2-40B4-BE49-F238E27FC236}">
+                <a16:creationId xmlns:a16="http://schemas.microsoft.com/office/drawing/2014/main" id="{FD0B50DC-89BD-B712-2D74-34FB9D9D87A0}"/>
               </a:ext>
             </a:extLst>
           </p:cNvPr>
@@ -8032,8 +8167,8 @@
         </p:nvSpPr>
         <p:spPr>
           <a:xfrm>
-            <a:off x="640080" y="1463040"/>
-            <a:ext cx="6217920" cy="369332"/>
+            <a:off x="548640" y="987552"/>
+            <a:ext cx="10607040" cy="369332"/>
           </a:xfrm>
           <a:prstGeom prst="rect">
             <a:avLst/>
@@ -8047,24 +8182,124 @@
           <a:lstStyle/>
           <a:p>
             <a:r>
-              <a:rPr lang="zh-CN" altLang="en-US" sz="1700" b="1">
-                <a:solidFill>
-                  <a:srgbClr val="C61720"/>
-                </a:solidFill>
-                <a:latin typeface="Microsoft YaHei" panose="020B0503020204020204" pitchFamily="34" charset="-122"/>
-                <a:ea typeface="Microsoft YaHei" panose="020B0503020204020204" pitchFamily="34" charset="-122"/>
-              </a:rPr>
-              <a:t>作业五步</a:t>
-            </a:r>
-          </a:p>
-        </p:txBody>
-      </p:sp>
-      <p:sp>
-        <p:nvSpPr>
-          <p:cNvPr id="4" name="文本框 3">
-            <a:extLst>
-              <a:ext uri="{FF2B5EF4-FFF2-40B4-BE49-F238E27FC236}">
-                <a16:creationId xmlns:a16="http://schemas.microsoft.com/office/drawing/2014/main" id="{B7DE68EA-D6BB-DAF3-BBA2-744A6A7995A2}"/>
+              <a:rPr lang="zh-CN" altLang="en-US" sz="1400">
+                <a:solidFill>
+                  <a:srgbClr val="66747C"/>
+                </a:solidFill>
+                <a:latin typeface="Microsoft YaHei" panose="020B0503020204020204" pitchFamily="34" charset="-122"/>
+                <a:ea typeface="Microsoft YaHei" panose="020B0503020204020204" pitchFamily="34" charset="-122"/>
+              </a:rPr>
+              <a:t>对象 </a:t>
+            </a:r>
+            <a:r>
+              <a:rPr lang="en-US" altLang="zh-CN" sz="1400">
+                <a:solidFill>
+                  <a:srgbClr val="66747C"/>
+                </a:solidFill>
+                <a:latin typeface="Microsoft YaHei" panose="020B0503020204020204" pitchFamily="34" charset="-122"/>
+                <a:ea typeface="Microsoft YaHei" panose="020B0503020204020204" pitchFamily="34" charset="-122"/>
+              </a:rPr>
+              <a:t>· </a:t>
+            </a:r>
+            <a:r>
+              <a:rPr lang="zh-CN" altLang="en-US" sz="1400">
+                <a:solidFill>
+                  <a:srgbClr val="66747C"/>
+                </a:solidFill>
+                <a:latin typeface="Microsoft YaHei" panose="020B0503020204020204" pitchFamily="34" charset="-122"/>
+                <a:ea typeface="Microsoft YaHei" panose="020B0503020204020204" pitchFamily="34" charset="-122"/>
+              </a:rPr>
+              <a:t>动作 </a:t>
+            </a:r>
+            <a:r>
+              <a:rPr lang="en-US" altLang="zh-CN" sz="1400">
+                <a:solidFill>
+                  <a:srgbClr val="66747C"/>
+                </a:solidFill>
+                <a:latin typeface="Microsoft YaHei" panose="020B0503020204020204" pitchFamily="34" charset="-122"/>
+                <a:ea typeface="Microsoft YaHei" panose="020B0503020204020204" pitchFamily="34" charset="-122"/>
+              </a:rPr>
+              <a:t>· </a:t>
+            </a:r>
+            <a:r>
+              <a:rPr lang="zh-CN" altLang="en-US" sz="1400">
+                <a:solidFill>
+                  <a:srgbClr val="66747C"/>
+                </a:solidFill>
+                <a:latin typeface="Microsoft YaHei" panose="020B0503020204020204" pitchFamily="34" charset="-122"/>
+                <a:ea typeface="Microsoft YaHei" panose="020B0503020204020204" pitchFamily="34" charset="-122"/>
+              </a:rPr>
+              <a:t>责任人 </a:t>
+            </a:r>
+            <a:r>
+              <a:rPr lang="en-US" altLang="zh-CN" sz="1400">
+                <a:solidFill>
+                  <a:srgbClr val="66747C"/>
+                </a:solidFill>
+                <a:latin typeface="Microsoft YaHei" panose="020B0503020204020204" pitchFamily="34" charset="-122"/>
+                <a:ea typeface="Microsoft YaHei" panose="020B0503020204020204" pitchFamily="34" charset="-122"/>
+              </a:rPr>
+              <a:t>· </a:t>
+            </a:r>
+            <a:r>
+              <a:rPr lang="zh-CN" altLang="en-US" sz="1400">
+                <a:solidFill>
+                  <a:srgbClr val="66747C"/>
+                </a:solidFill>
+                <a:latin typeface="Microsoft YaHei" panose="020B0503020204020204" pitchFamily="34" charset="-122"/>
+                <a:ea typeface="Microsoft YaHei" panose="020B0503020204020204" pitchFamily="34" charset="-122"/>
+              </a:rPr>
+              <a:t>节点 </a:t>
+            </a:r>
+            <a:r>
+              <a:rPr lang="en-US" altLang="zh-CN" sz="1400">
+                <a:solidFill>
+                  <a:srgbClr val="66747C"/>
+                </a:solidFill>
+                <a:latin typeface="Microsoft YaHei" panose="020B0503020204020204" pitchFamily="34" charset="-122"/>
+                <a:ea typeface="Microsoft YaHei" panose="020B0503020204020204" pitchFamily="34" charset="-122"/>
+              </a:rPr>
+              <a:t>· </a:t>
+            </a:r>
+            <a:r>
+              <a:rPr lang="zh-CN" altLang="en-US" sz="1400">
+                <a:solidFill>
+                  <a:srgbClr val="66747C"/>
+                </a:solidFill>
+                <a:latin typeface="Microsoft YaHei" panose="020B0503020204020204" pitchFamily="34" charset="-122"/>
+                <a:ea typeface="Microsoft YaHei" panose="020B0503020204020204" pitchFamily="34" charset="-122"/>
+              </a:rPr>
+              <a:t>指标</a:t>
+            </a:r>
+            <a:r>
+              <a:rPr lang="en-US" altLang="zh-CN" sz="1400">
+                <a:solidFill>
+                  <a:srgbClr val="66747C"/>
+                </a:solidFill>
+                <a:latin typeface="Microsoft YaHei" panose="020B0503020204020204" pitchFamily="34" charset="-122"/>
+                <a:ea typeface="Microsoft YaHei" panose="020B0503020204020204" pitchFamily="34" charset="-122"/>
+              </a:rPr>
+              <a:t>——</a:t>
+            </a:r>
+            <a:r>
+              <a:rPr lang="zh-CN" altLang="en-US" sz="1400">
+                <a:solidFill>
+                  <a:srgbClr val="66747C"/>
+                </a:solidFill>
+                <a:latin typeface="Microsoft YaHei" panose="020B0503020204020204" pitchFamily="34" charset="-122"/>
+                <a:ea typeface="Microsoft YaHei" panose="020B0503020204020204" pitchFamily="34" charset="-122"/>
+              </a:rPr>
+              <a:t>每项行动都要能检查</a:t>
+            </a:r>
+          </a:p>
+        </p:txBody>
+      </p:sp>
+      <p:sp>
+        <p:nvSpPr>
+          <p:cNvPr id="4" name="COL_OBJECT">
+            <a:extLst>
+              <a:ext uri="{FF2B5EF4-FFF2-40B4-BE49-F238E27FC236}">
+                <a16:creationId xmlns:a16="http://schemas.microsoft.com/office/drawing/2014/main" id="{83B3AA92-49F6-BA39-4B2D-AB10FD477E09}"/>
               </a:ext>
             </a:extLst>
           </p:cNvPr>
@@ -8073,8 +8308,8 @@
         </p:nvSpPr>
         <p:spPr>
           <a:xfrm>
-            <a:off x="640080" y="2057400"/>
-            <a:ext cx="6217920" cy="369332"/>
+            <a:off x="731520" y="1463040"/>
+            <a:ext cx="1737360" cy="369332"/>
           </a:xfrm>
           <a:prstGeom prst="rect">
             <a:avLst/>
@@ -8087,148 +8322,25 @@
           </a:bodyPr>
           <a:lstStyle/>
           <a:p>
-            <a:pPr>
-              <a:lnSpc>
-                <a:spcPct val="140000"/>
-              </a:lnSpc>
-            </a:pPr>
-            <a:r>
-              <a:rPr lang="en-US" altLang="zh-CN" sz="1400">
-                <a:solidFill>
-                  <a:srgbClr val="172A3A"/>
-                </a:solidFill>
-                <a:latin typeface="Microsoft YaHei" panose="020B0503020204020204" pitchFamily="34" charset="-122"/>
-                <a:ea typeface="Microsoft YaHei" panose="020B0503020204020204" pitchFamily="34" charset="-122"/>
-              </a:rPr>
-              <a:t>1. </a:t>
-            </a:r>
-            <a:r>
-              <a:rPr lang="zh-CN" altLang="en-US" sz="1400">
-                <a:solidFill>
-                  <a:srgbClr val="172A3A"/>
-                </a:solidFill>
-                <a:latin typeface="Microsoft YaHei" panose="020B0503020204020204" pitchFamily="34" charset="-122"/>
-                <a:ea typeface="Microsoft YaHei" panose="020B0503020204020204" pitchFamily="34" charset="-122"/>
-              </a:rPr>
-              <a:t>标出县城和主要乡镇</a:t>
-            </a:r>
-          </a:p>
-          <a:p>
-            <a:pPr>
-              <a:lnSpc>
-                <a:spcPct val="140000"/>
-              </a:lnSpc>
-            </a:pPr>
-            <a:r>
-              <a:rPr lang="en-US" altLang="zh-CN" sz="1400">
-                <a:solidFill>
-                  <a:srgbClr val="172A3A"/>
-                </a:solidFill>
-                <a:latin typeface="Microsoft YaHei" panose="020B0503020204020204" pitchFamily="34" charset="-122"/>
-                <a:ea typeface="Microsoft YaHei" panose="020B0503020204020204" pitchFamily="34" charset="-122"/>
-              </a:rPr>
-              <a:t>2. </a:t>
-            </a:r>
-            <a:r>
-              <a:rPr lang="zh-CN" altLang="en-US" sz="1400">
-                <a:solidFill>
-                  <a:srgbClr val="172A3A"/>
-                </a:solidFill>
-                <a:latin typeface="Microsoft YaHei" panose="020B0503020204020204" pitchFamily="34" charset="-122"/>
-                <a:ea typeface="Microsoft YaHei" panose="020B0503020204020204" pitchFamily="34" charset="-122"/>
-              </a:rPr>
-              <a:t>判断各乡镇属于「进得去、站得住、卖得动、做得深」中的哪种状态</a:t>
-            </a:r>
-          </a:p>
-          <a:p>
-            <a:pPr>
-              <a:lnSpc>
-                <a:spcPct val="140000"/>
-              </a:lnSpc>
-            </a:pPr>
-            <a:r>
-              <a:rPr lang="en-US" altLang="zh-CN" sz="1400">
-                <a:solidFill>
-                  <a:srgbClr val="172A3A"/>
-                </a:solidFill>
-                <a:latin typeface="Microsoft YaHei" panose="020B0503020204020204" pitchFamily="34" charset="-122"/>
-                <a:ea typeface="Microsoft YaHei" panose="020B0503020204020204" pitchFamily="34" charset="-122"/>
-              </a:rPr>
-              <a:t>3. </a:t>
-            </a:r>
-            <a:r>
-              <a:rPr lang="zh-CN" altLang="en-US" sz="1400">
-                <a:solidFill>
-                  <a:srgbClr val="172A3A"/>
-                </a:solidFill>
-                <a:latin typeface="Microsoft YaHei" panose="020B0503020204020204" pitchFamily="34" charset="-122"/>
-                <a:ea typeface="Microsoft YaHei" panose="020B0503020204020204" pitchFamily="34" charset="-122"/>
-              </a:rPr>
-              <a:t>标出重点乡镇最明显的四力短板</a:t>
-            </a:r>
-          </a:p>
-          <a:p>
-            <a:pPr>
-              <a:lnSpc>
-                <a:spcPct val="140000"/>
-              </a:lnSpc>
-            </a:pPr>
-            <a:r>
-              <a:rPr lang="en-US" altLang="zh-CN" sz="1400">
-                <a:solidFill>
-                  <a:srgbClr val="172A3A"/>
-                </a:solidFill>
-                <a:latin typeface="Microsoft YaHei" panose="020B0503020204020204" pitchFamily="34" charset="-122"/>
-                <a:ea typeface="Microsoft YaHei" panose="020B0503020204020204" pitchFamily="34" charset="-122"/>
-              </a:rPr>
-              <a:t>4. </a:t>
-            </a:r>
-            <a:r>
-              <a:rPr lang="zh-CN" altLang="en-US" sz="1400">
-                <a:solidFill>
-                  <a:srgbClr val="172A3A"/>
-                </a:solidFill>
-                <a:latin typeface="Microsoft YaHei" panose="020B0503020204020204" pitchFamily="34" charset="-122"/>
-                <a:ea typeface="Microsoft YaHei" panose="020B0503020204020204" pitchFamily="34" charset="-122"/>
-              </a:rPr>
-              <a:t>初步区分需要继续深耕和需要进一步评估的乡镇</a:t>
-            </a:r>
-          </a:p>
-          <a:p>
-            <a:pPr>
-              <a:lnSpc>
-                <a:spcPct val="140000"/>
-              </a:lnSpc>
-            </a:pPr>
-            <a:r>
-              <a:rPr lang="en-US" altLang="zh-CN" sz="1400">
-                <a:solidFill>
-                  <a:srgbClr val="172A3A"/>
-                </a:solidFill>
-                <a:latin typeface="Microsoft YaHei" panose="020B0503020204020204" pitchFamily="34" charset="-122"/>
-                <a:ea typeface="Microsoft YaHei" panose="020B0503020204020204" pitchFamily="34" charset="-122"/>
-              </a:rPr>
-              <a:t>5. </a:t>
-            </a:r>
-            <a:r>
-              <a:rPr lang="zh-CN" altLang="en-US" sz="1400">
-                <a:solidFill>
-                  <a:srgbClr val="172A3A"/>
-                </a:solidFill>
-                <a:latin typeface="Microsoft YaHei" panose="020B0503020204020204" pitchFamily="34" charset="-122"/>
-                <a:ea typeface="Microsoft YaHei" panose="020B0503020204020204" pitchFamily="34" charset="-122"/>
-              </a:rPr>
-              <a:t>由经销商与雨虹县长课后共同补充真实信息</a:t>
-            </a:r>
-          </a:p>
-        </p:txBody>
-      </p:sp>
-      <p:sp>
-        <p:nvSpPr>
-          <p:cNvPr id="5" name="文本框 4">
-            <a:extLst>
-              <a:ext uri="{FF2B5EF4-FFF2-40B4-BE49-F238E27FC236}">
-                <a16:creationId xmlns:a16="http://schemas.microsoft.com/office/drawing/2014/main" id="{0C9463DE-9071-EF11-C3FE-AAC635E037C9}"/>
+            <a:r>
+              <a:rPr lang="zh-CN" altLang="en-US" sz="1300" b="1">
+                <a:solidFill>
+                  <a:srgbClr val="C61720"/>
+                </a:solidFill>
+                <a:latin typeface="Microsoft YaHei" panose="020B0503020204020204" pitchFamily="34" charset="-122"/>
+                <a:ea typeface="Microsoft YaHei" panose="020B0503020204020204" pitchFamily="34" charset="-122"/>
+              </a:rPr>
+              <a:t>对象</a:t>
+            </a:r>
+          </a:p>
+        </p:txBody>
+      </p:sp>
+      <p:sp>
+        <p:nvSpPr>
+          <p:cNvPr id="5" name="COL_ACTION">
+            <a:extLst>
+              <a:ext uri="{FF2B5EF4-FFF2-40B4-BE49-F238E27FC236}">
+                <a16:creationId xmlns:a16="http://schemas.microsoft.com/office/drawing/2014/main" id="{701EFBC3-E701-A1A0-EE55-03A76C47D22A}"/>
               </a:ext>
             </a:extLst>
           </p:cNvPr>
@@ -8237,8 +8349,8 @@
         </p:nvSpPr>
         <p:spPr>
           <a:xfrm>
-            <a:off x="7223760" y="1463040"/>
-            <a:ext cx="4480560" cy="369332"/>
+            <a:off x="2606040" y="1463040"/>
+            <a:ext cx="3840480" cy="369332"/>
           </a:xfrm>
           <a:prstGeom prst="rect">
             <a:avLst/>
@@ -8259,17 +8371,17 @@
                 <a:latin typeface="Microsoft YaHei" panose="020B0503020204020204" pitchFamily="34" charset="-122"/>
                 <a:ea typeface="Microsoft YaHei" panose="020B0503020204020204" pitchFamily="34" charset="-122"/>
               </a:rPr>
-              <a:t>示例（匿名化综合案例，仅说明填法）</a:t>
-            </a:r>
-          </a:p>
-        </p:txBody>
-      </p:sp>
-      <p:sp>
-        <p:nvSpPr>
-          <p:cNvPr id="6" name="文本框 5">
-            <a:extLst>
-              <a:ext uri="{FF2B5EF4-FFF2-40B4-BE49-F238E27FC236}">
-                <a16:creationId xmlns:a16="http://schemas.microsoft.com/office/drawing/2014/main" id="{968EA0DC-2241-A72D-60A2-A20BAC8E512F}"/>
+              <a:t>动作</a:t>
+            </a:r>
+          </a:p>
+        </p:txBody>
+      </p:sp>
+      <p:sp>
+        <p:nvSpPr>
+          <p:cNvPr id="6" name="COL_OWNER">
+            <a:extLst>
+              <a:ext uri="{FF2B5EF4-FFF2-40B4-BE49-F238E27FC236}">
+                <a16:creationId xmlns:a16="http://schemas.microsoft.com/office/drawing/2014/main" id="{96185530-8BEE-7E0B-6C83-6D64F613C653}"/>
               </a:ext>
             </a:extLst>
           </p:cNvPr>
@@ -8278,8 +8390,8 @@
         </p:nvSpPr>
         <p:spPr>
           <a:xfrm>
-            <a:off x="7223760" y="2057400"/>
-            <a:ext cx="4480560" cy="369332"/>
+            <a:off x="6583680" y="1463040"/>
+            <a:ext cx="1554480" cy="369332"/>
           </a:xfrm>
           <a:prstGeom prst="rect">
             <a:avLst/>
@@ -8292,30 +8404,25 @@
           </a:bodyPr>
           <a:lstStyle/>
           <a:p>
-            <a:pPr>
-              <a:lnSpc>
-                <a:spcPct val="130000"/>
-              </a:lnSpc>
-            </a:pPr>
-            <a:r>
-              <a:rPr lang="zh-CN" altLang="en-US" sz="1200">
-                <a:solidFill>
-                  <a:srgbClr val="66747C"/>
-                </a:solidFill>
-                <a:latin typeface="Microsoft YaHei" panose="020B0503020204020204" pitchFamily="34" charset="-122"/>
-                <a:ea typeface="Microsoft YaHei" panose="020B0503020204020204" pitchFamily="34" charset="-122"/>
-              </a:rPr>
-              <a:t>某县经销商早期在多个乡镇平均跑动、广撒网点，后来把资源集中到机场周边两个重点乡镇：县城做仓储配送和品牌展示，两个重点镇各建一个核心网点连接工人和包工头，乡镇业务占比达到六成以上，实现从「乡镇都去过」到「重点乡镇做透」的转变。</a:t>
-            </a:r>
-          </a:p>
-        </p:txBody>
-      </p:sp>
-      <p:sp>
-        <p:nvSpPr>
-          <p:cNvPr id="7" name="文本框 6">
-            <a:extLst>
-              <a:ext uri="{FF2B5EF4-FFF2-40B4-BE49-F238E27FC236}">
-                <a16:creationId xmlns:a16="http://schemas.microsoft.com/office/drawing/2014/main" id="{702B6087-107D-F919-A6CD-52EEC4CEAE11}"/>
+            <a:r>
+              <a:rPr lang="zh-CN" altLang="en-US" sz="1300" b="1">
+                <a:solidFill>
+                  <a:srgbClr val="C61720"/>
+                </a:solidFill>
+                <a:latin typeface="Microsoft YaHei" panose="020B0503020204020204" pitchFamily="34" charset="-122"/>
+                <a:ea typeface="Microsoft YaHei" panose="020B0503020204020204" pitchFamily="34" charset="-122"/>
+              </a:rPr>
+              <a:t>责任人</a:t>
+            </a:r>
+          </a:p>
+        </p:txBody>
+      </p:sp>
+      <p:sp>
+        <p:nvSpPr>
+          <p:cNvPr id="7" name="COL_DATE">
+            <a:extLst>
+              <a:ext uri="{FF2B5EF4-FFF2-40B4-BE49-F238E27FC236}">
+                <a16:creationId xmlns:a16="http://schemas.microsoft.com/office/drawing/2014/main" id="{307A33D4-CF80-CF50-EA8A-BB37A5303229}"/>
               </a:ext>
             </a:extLst>
           </p:cNvPr>
@@ -8324,8 +8431,8 @@
         </p:nvSpPr>
         <p:spPr>
           <a:xfrm>
-            <a:off x="640080" y="5943600"/>
-            <a:ext cx="10881360" cy="369332"/>
+            <a:off x="8229600" y="1463040"/>
+            <a:ext cx="1554480" cy="369332"/>
           </a:xfrm>
           <a:prstGeom prst="rect">
             <a:avLst/>
@@ -8338,16 +8445,1408 @@
           </a:bodyPr>
           <a:lstStyle/>
           <a:p>
+            <a:r>
+              <a:rPr lang="zh-CN" altLang="en-US" sz="1300" b="1">
+                <a:solidFill>
+                  <a:srgbClr val="C61720"/>
+                </a:solidFill>
+                <a:latin typeface="Microsoft YaHei" panose="020B0503020204020204" pitchFamily="34" charset="-122"/>
+                <a:ea typeface="Microsoft YaHei" panose="020B0503020204020204" pitchFamily="34" charset="-122"/>
+              </a:rPr>
+              <a:t>节点</a:t>
+            </a:r>
+          </a:p>
+        </p:txBody>
+      </p:sp>
+      <p:sp>
+        <p:nvSpPr>
+          <p:cNvPr id="8" name="COL_METRIC">
+            <a:extLst>
+              <a:ext uri="{FF2B5EF4-FFF2-40B4-BE49-F238E27FC236}">
+                <a16:creationId xmlns:a16="http://schemas.microsoft.com/office/drawing/2014/main" id="{8A46E780-5ABD-BEA3-BE8B-950DF52B954C}"/>
+              </a:ext>
+            </a:extLst>
+          </p:cNvPr>
+          <p:cNvSpPr txBox="1"/>
+          <p:nvPr/>
+        </p:nvSpPr>
+        <p:spPr>
+          <a:xfrm>
+            <a:off x="9921240" y="1463040"/>
+            <a:ext cx="2011680" cy="369332"/>
+          </a:xfrm>
+          <a:prstGeom prst="rect">
+            <a:avLst/>
+          </a:prstGeom>
+          <a:noFill/>
+        </p:spPr>
+        <p:txBody>
+          <a:bodyPr vert="horz" wrap="square" rtlCol="0">
+            <a:noAutofit/>
+          </a:bodyPr>
+          <a:lstStyle/>
+          <a:p>
+            <a:r>
+              <a:rPr lang="zh-CN" altLang="en-US" sz="1300" b="1">
+                <a:solidFill>
+                  <a:srgbClr val="C61720"/>
+                </a:solidFill>
+                <a:latin typeface="Microsoft YaHei" panose="020B0503020204020204" pitchFamily="34" charset="-122"/>
+                <a:ea typeface="Microsoft YaHei" panose="020B0503020204020204" pitchFamily="34" charset="-122"/>
+              </a:rPr>
+              <a:t>指标</a:t>
+            </a:r>
+          </a:p>
+        </p:txBody>
+      </p:sp>
+      <p:sp>
+        <p:nvSpPr>
+          <p:cNvPr id="9" name="ROW_BAND_1">
+            <a:extLst>
+              <a:ext uri="{FF2B5EF4-FFF2-40B4-BE49-F238E27FC236}">
+                <a16:creationId xmlns:a16="http://schemas.microsoft.com/office/drawing/2014/main" id="{2E9F722F-0AD7-C93C-D78D-319BC4DBC193}"/>
+              </a:ext>
+            </a:extLst>
+          </p:cNvPr>
+          <p:cNvSpPr/>
+          <p:nvPr/>
+        </p:nvSpPr>
+        <p:spPr>
+          <a:xfrm>
+            <a:off x="594360" y="1965960"/>
+            <a:ext cx="11155680" cy="822960"/>
+          </a:xfrm>
+          <a:prstGeom prst="rect">
+            <a:avLst/>
+          </a:prstGeom>
+          <a:solidFill>
+            <a:srgbClr val="F0F1EF"/>
+          </a:solidFill>
+          <a:ln w="9525">
+            <a:solidFill>
+              <a:srgbClr val="66747C"/>
+            </a:solidFill>
+          </a:ln>
+        </p:spPr>
+        <p:style>
+          <a:lnRef idx="2">
+            <a:schemeClr val="accent1">
+              <a:shade val="15000"/>
+            </a:schemeClr>
+          </a:lnRef>
+          <a:fillRef idx="1">
+            <a:schemeClr val="accent1"/>
+          </a:fillRef>
+          <a:effectRef idx="0">
+            <a:schemeClr val="accent1"/>
+          </a:effectRef>
+          <a:fontRef idx="minor">
+            <a:schemeClr val="lt1"/>
+          </a:fontRef>
+        </p:style>
+        <p:txBody>
+          <a:bodyPr rtlCol="0" anchor="ctr"/>
+          <a:lstStyle/>
+          <a:p>
             <a:pPr algn="ctr"/>
-            <a:r>
-              <a:rPr lang="zh-CN" altLang="en-US" sz="1500" b="1">
-                <a:solidFill>
-                  <a:srgbClr val="C61720"/>
-                </a:solidFill>
-                <a:latin typeface="Microsoft YaHei" panose="020B0503020204020204" pitchFamily="34" charset="-122"/>
-                <a:ea typeface="Microsoft YaHei" panose="020B0503020204020204" pitchFamily="34" charset="-122"/>
-              </a:rPr>
-              <a:t>这张版图是下一步「盘区域」的输入：判状态看现状，盘区域看外部机会，做完才能决定资源投到哪里。</a:t>
+            <a:endParaRPr lang="zh-CN" altLang="en-US"/>
+          </a:p>
+        </p:txBody>
+      </p:sp>
+      <p:sp>
+        <p:nvSpPr>
+          <p:cNvPr id="10" name="ACT_01_OBJECT">
+            <a:extLst>
+              <a:ext uri="{FF2B5EF4-FFF2-40B4-BE49-F238E27FC236}">
+                <a16:creationId xmlns:a16="http://schemas.microsoft.com/office/drawing/2014/main" id="{23049707-75D2-6904-74C7-8B534D4649FA}"/>
+              </a:ext>
+            </a:extLst>
+          </p:cNvPr>
+          <p:cNvSpPr txBox="1"/>
+          <p:nvPr/>
+        </p:nvSpPr>
+        <p:spPr>
+          <a:xfrm>
+            <a:off x="731520" y="2167128"/>
+            <a:ext cx="1737360" cy="369332"/>
+          </a:xfrm>
+          <a:prstGeom prst="rect">
+            <a:avLst/>
+          </a:prstGeom>
+          <a:noFill/>
+        </p:spPr>
+        <p:txBody>
+          <a:bodyPr vert="horz" wrap="square" rtlCol="0">
+            <a:noAutofit/>
+          </a:bodyPr>
+          <a:lstStyle/>
+          <a:p>
+            <a:r>
+              <a:rPr lang="zh-CN" altLang="en-US" sz="1300">
+                <a:solidFill>
+                  <a:srgbClr val="172A3A"/>
+                </a:solidFill>
+                <a:latin typeface="Microsoft YaHei" panose="020B0503020204020204" pitchFamily="34" charset="-122"/>
+                <a:ea typeface="Microsoft YaHei" panose="020B0503020204020204" pitchFamily="34" charset="-122"/>
+              </a:rPr>
+              <a:t>乡镇①（做深）</a:t>
+            </a:r>
+          </a:p>
+        </p:txBody>
+      </p:sp>
+      <p:sp>
+        <p:nvSpPr>
+          <p:cNvPr id="11" name="ACT_01_ACTION">
+            <a:extLst>
+              <a:ext uri="{FF2B5EF4-FFF2-40B4-BE49-F238E27FC236}">
+                <a16:creationId xmlns:a16="http://schemas.microsoft.com/office/drawing/2014/main" id="{B0DD80EF-B808-545A-70A5-D558A4390E39}"/>
+              </a:ext>
+            </a:extLst>
+          </p:cNvPr>
+          <p:cNvSpPr txBox="1"/>
+          <p:nvPr/>
+        </p:nvSpPr>
+        <p:spPr>
+          <a:xfrm>
+            <a:off x="2606040" y="2167128"/>
+            <a:ext cx="3840480" cy="369332"/>
+          </a:xfrm>
+          <a:prstGeom prst="rect">
+            <a:avLst/>
+          </a:prstGeom>
+          <a:noFill/>
+        </p:spPr>
+        <p:txBody>
+          <a:bodyPr vert="horz" wrap="square" rtlCol="0">
+            <a:noAutofit/>
+          </a:bodyPr>
+          <a:lstStyle/>
+          <a:p>
+            <a:r>
+              <a:rPr lang="zh-CN" altLang="en-US" sz="1300">
+                <a:solidFill>
+                  <a:srgbClr val="172A3A"/>
+                </a:solidFill>
+                <a:latin typeface="Microsoft YaHei" panose="020B0503020204020204" pitchFamily="34" charset="-122"/>
+                <a:ea typeface="Microsoft YaHei" panose="020B0503020204020204" pitchFamily="34" charset="-122"/>
+              </a:rPr>
+              <a:t>核心网点连续跟进补货与项目线索</a:t>
+            </a:r>
+          </a:p>
+        </p:txBody>
+      </p:sp>
+      <p:sp>
+        <p:nvSpPr>
+          <p:cNvPr id="12" name="ACT_01_OWNER">
+            <a:extLst>
+              <a:ext uri="{FF2B5EF4-FFF2-40B4-BE49-F238E27FC236}">
+                <a16:creationId xmlns:a16="http://schemas.microsoft.com/office/drawing/2014/main" id="{7BB6BC82-0D29-C4DD-5848-F241776B9402}"/>
+              </a:ext>
+            </a:extLst>
+          </p:cNvPr>
+          <p:cNvSpPr txBox="1"/>
+          <p:nvPr/>
+        </p:nvSpPr>
+        <p:spPr>
+          <a:xfrm>
+            <a:off x="6583680" y="2167128"/>
+            <a:ext cx="1554480" cy="369332"/>
+          </a:xfrm>
+          <a:prstGeom prst="rect">
+            <a:avLst/>
+          </a:prstGeom>
+          <a:noFill/>
+        </p:spPr>
+        <p:txBody>
+          <a:bodyPr vert="horz" wrap="square" rtlCol="0">
+            <a:noAutofit/>
+          </a:bodyPr>
+          <a:lstStyle/>
+          <a:p>
+            <a:r>
+              <a:rPr lang="en-US" altLang="zh-CN" sz="1300">
+                <a:solidFill>
+                  <a:srgbClr val="172A3A"/>
+                </a:solidFill>
+                <a:latin typeface="Microsoft YaHei" panose="020B0503020204020204" pitchFamily="34" charset="-122"/>
+                <a:ea typeface="Microsoft YaHei" panose="020B0503020204020204" pitchFamily="34" charset="-122"/>
+              </a:rPr>
+              <a:t>____</a:t>
+            </a:r>
+            <a:endParaRPr lang="zh-CN" altLang="en-US" sz="1300">
+              <a:solidFill>
+                <a:srgbClr val="172A3A"/>
+              </a:solidFill>
+              <a:latin typeface="Microsoft YaHei" panose="020B0503020204020204" pitchFamily="34" charset="-122"/>
+              <a:ea typeface="Microsoft YaHei" panose="020B0503020204020204" pitchFamily="34" charset="-122"/>
+            </a:endParaRPr>
+          </a:p>
+        </p:txBody>
+      </p:sp>
+      <p:sp>
+        <p:nvSpPr>
+          <p:cNvPr id="13" name="ACT_01_DATE">
+            <a:extLst>
+              <a:ext uri="{FF2B5EF4-FFF2-40B4-BE49-F238E27FC236}">
+                <a16:creationId xmlns:a16="http://schemas.microsoft.com/office/drawing/2014/main" id="{F8DBB096-DB44-C664-2A40-DF8D09F9BC94}"/>
+              </a:ext>
+            </a:extLst>
+          </p:cNvPr>
+          <p:cNvSpPr txBox="1"/>
+          <p:nvPr/>
+        </p:nvSpPr>
+        <p:spPr>
+          <a:xfrm>
+            <a:off x="8229600" y="2167128"/>
+            <a:ext cx="1554480" cy="369332"/>
+          </a:xfrm>
+          <a:prstGeom prst="rect">
+            <a:avLst/>
+          </a:prstGeom>
+          <a:noFill/>
+        </p:spPr>
+        <p:txBody>
+          <a:bodyPr vert="horz" wrap="square" rtlCol="0">
+            <a:noAutofit/>
+          </a:bodyPr>
+          <a:lstStyle/>
+          <a:p>
+            <a:r>
+              <a:rPr lang="zh-CN" altLang="en-US" sz="1300">
+                <a:solidFill>
+                  <a:srgbClr val="172A3A"/>
+                </a:solidFill>
+                <a:latin typeface="Microsoft YaHei" panose="020B0503020204020204" pitchFamily="34" charset="-122"/>
+                <a:ea typeface="Microsoft YaHei" panose="020B0503020204020204" pitchFamily="34" charset="-122"/>
+              </a:rPr>
+              <a:t>第</a:t>
+            </a:r>
+            <a:r>
+              <a:rPr lang="en-US" altLang="zh-CN" sz="1300">
+                <a:solidFill>
+                  <a:srgbClr val="172A3A"/>
+                </a:solidFill>
+                <a:latin typeface="Microsoft YaHei" panose="020B0503020204020204" pitchFamily="34" charset="-122"/>
+                <a:ea typeface="Microsoft YaHei" panose="020B0503020204020204" pitchFamily="34" charset="-122"/>
+              </a:rPr>
+              <a:t>1-2</a:t>
+            </a:r>
+            <a:r>
+              <a:rPr lang="zh-CN" altLang="en-US" sz="1300">
+                <a:solidFill>
+                  <a:srgbClr val="172A3A"/>
+                </a:solidFill>
+                <a:latin typeface="Microsoft YaHei" panose="020B0503020204020204" pitchFamily="34" charset="-122"/>
+                <a:ea typeface="Microsoft YaHei" panose="020B0503020204020204" pitchFamily="34" charset="-122"/>
+              </a:rPr>
+              <a:t>周</a:t>
+            </a:r>
+          </a:p>
+        </p:txBody>
+      </p:sp>
+      <p:sp>
+        <p:nvSpPr>
+          <p:cNvPr id="14" name="ACT_01_METRIC">
+            <a:extLst>
+              <a:ext uri="{FF2B5EF4-FFF2-40B4-BE49-F238E27FC236}">
+                <a16:creationId xmlns:a16="http://schemas.microsoft.com/office/drawing/2014/main" id="{3895D914-22F0-24E2-1B79-9C48F57E4690}"/>
+              </a:ext>
+            </a:extLst>
+          </p:cNvPr>
+          <p:cNvSpPr txBox="1"/>
+          <p:nvPr/>
+        </p:nvSpPr>
+        <p:spPr>
+          <a:xfrm>
+            <a:off x="9921240" y="2167128"/>
+            <a:ext cx="2011680" cy="369332"/>
+          </a:xfrm>
+          <a:prstGeom prst="rect">
+            <a:avLst/>
+          </a:prstGeom>
+          <a:noFill/>
+        </p:spPr>
+        <p:txBody>
+          <a:bodyPr vert="horz" wrap="square" rtlCol="0">
+            <a:noAutofit/>
+          </a:bodyPr>
+          <a:lstStyle/>
+          <a:p>
+            <a:r>
+              <a:rPr lang="zh-CN" altLang="en-US" sz="1300">
+                <a:solidFill>
+                  <a:srgbClr val="172A3A"/>
+                </a:solidFill>
+                <a:latin typeface="Microsoft YaHei" panose="020B0503020204020204" pitchFamily="34" charset="-122"/>
+                <a:ea typeface="Microsoft YaHei" panose="020B0503020204020204" pitchFamily="34" charset="-122"/>
+              </a:rPr>
+              <a:t>补货≥</a:t>
+            </a:r>
+            <a:r>
+              <a:rPr lang="en-US" altLang="zh-CN" sz="1300">
+                <a:solidFill>
+                  <a:srgbClr val="172A3A"/>
+                </a:solidFill>
+                <a:latin typeface="Microsoft YaHei" panose="020B0503020204020204" pitchFamily="34" charset="-122"/>
+                <a:ea typeface="Microsoft YaHei" panose="020B0503020204020204" pitchFamily="34" charset="-122"/>
+              </a:rPr>
+              <a:t>2</a:t>
+            </a:r>
+            <a:r>
+              <a:rPr lang="zh-CN" altLang="en-US" sz="1300">
+                <a:solidFill>
+                  <a:srgbClr val="172A3A"/>
+                </a:solidFill>
+                <a:latin typeface="Microsoft YaHei" panose="020B0503020204020204" pitchFamily="34" charset="-122"/>
+                <a:ea typeface="Microsoft YaHei" panose="020B0503020204020204" pitchFamily="34" charset="-122"/>
+              </a:rPr>
+              <a:t>次</a:t>
+            </a:r>
+          </a:p>
+        </p:txBody>
+      </p:sp>
+      <p:sp>
+        <p:nvSpPr>
+          <p:cNvPr id="15" name="ROW_BAND_2">
+            <a:extLst>
+              <a:ext uri="{FF2B5EF4-FFF2-40B4-BE49-F238E27FC236}">
+                <a16:creationId xmlns:a16="http://schemas.microsoft.com/office/drawing/2014/main" id="{A8A49739-37FD-C673-C2CD-31A6A39F2C2C}"/>
+              </a:ext>
+            </a:extLst>
+          </p:cNvPr>
+          <p:cNvSpPr/>
+          <p:nvPr/>
+        </p:nvSpPr>
+        <p:spPr>
+          <a:xfrm>
+            <a:off x="594360" y="2834640"/>
+            <a:ext cx="11155680" cy="822960"/>
+          </a:xfrm>
+          <a:prstGeom prst="rect">
+            <a:avLst/>
+          </a:prstGeom>
+          <a:solidFill>
+            <a:srgbClr val="F7E6E6"/>
+          </a:solidFill>
+          <a:ln w="9525">
+            <a:solidFill>
+              <a:srgbClr val="66747C"/>
+            </a:solidFill>
+          </a:ln>
+        </p:spPr>
+        <p:style>
+          <a:lnRef idx="2">
+            <a:schemeClr val="accent1">
+              <a:shade val="15000"/>
+            </a:schemeClr>
+          </a:lnRef>
+          <a:fillRef idx="1">
+            <a:schemeClr val="accent1"/>
+          </a:fillRef>
+          <a:effectRef idx="0">
+            <a:schemeClr val="accent1"/>
+          </a:effectRef>
+          <a:fontRef idx="minor">
+            <a:schemeClr val="lt1"/>
+          </a:fontRef>
+        </p:style>
+        <p:txBody>
+          <a:bodyPr rtlCol="0" anchor="ctr"/>
+          <a:lstStyle/>
+          <a:p>
+            <a:pPr algn="ctr"/>
+            <a:endParaRPr lang="zh-CN" altLang="en-US"/>
+          </a:p>
+        </p:txBody>
+      </p:sp>
+      <p:sp>
+        <p:nvSpPr>
+          <p:cNvPr id="16" name="ACT_02_OBJECT">
+            <a:extLst>
+              <a:ext uri="{FF2B5EF4-FFF2-40B4-BE49-F238E27FC236}">
+                <a16:creationId xmlns:a16="http://schemas.microsoft.com/office/drawing/2014/main" id="{8E6614A7-B3FC-976A-E99B-52E80219C6AC}"/>
+              </a:ext>
+            </a:extLst>
+          </p:cNvPr>
+          <p:cNvSpPr txBox="1"/>
+          <p:nvPr/>
+        </p:nvSpPr>
+        <p:spPr>
+          <a:xfrm>
+            <a:off x="731520" y="3035808"/>
+            <a:ext cx="1737360" cy="369332"/>
+          </a:xfrm>
+          <a:prstGeom prst="rect">
+            <a:avLst/>
+          </a:prstGeom>
+          <a:noFill/>
+        </p:spPr>
+        <p:txBody>
+          <a:bodyPr vert="horz" wrap="square" rtlCol="0">
+            <a:noAutofit/>
+          </a:bodyPr>
+          <a:lstStyle/>
+          <a:p>
+            <a:r>
+              <a:rPr lang="zh-CN" altLang="en-US" sz="1300">
+                <a:solidFill>
+                  <a:srgbClr val="172A3A"/>
+                </a:solidFill>
+                <a:latin typeface="Microsoft YaHei" panose="020B0503020204020204" pitchFamily="34" charset="-122"/>
+                <a:ea typeface="Microsoft YaHei" panose="020B0503020204020204" pitchFamily="34" charset="-122"/>
+              </a:rPr>
+              <a:t>乡镇③（开拓）</a:t>
+            </a:r>
+          </a:p>
+        </p:txBody>
+      </p:sp>
+      <p:sp>
+        <p:nvSpPr>
+          <p:cNvPr id="17" name="ACT_02_ACTION">
+            <a:extLst>
+              <a:ext uri="{FF2B5EF4-FFF2-40B4-BE49-F238E27FC236}">
+                <a16:creationId xmlns:a16="http://schemas.microsoft.com/office/drawing/2014/main" id="{7919B6F1-6E34-D4DC-773D-299B298078B7}"/>
+              </a:ext>
+            </a:extLst>
+          </p:cNvPr>
+          <p:cNvSpPr txBox="1"/>
+          <p:nvPr/>
+        </p:nvSpPr>
+        <p:spPr>
+          <a:xfrm>
+            <a:off x="2606040" y="3035808"/>
+            <a:ext cx="3840480" cy="369332"/>
+          </a:xfrm>
+          <a:prstGeom prst="rect">
+            <a:avLst/>
+          </a:prstGeom>
+          <a:noFill/>
+        </p:spPr>
+        <p:txBody>
+          <a:bodyPr vert="horz" wrap="square" rtlCol="0">
+            <a:noAutofit/>
+          </a:bodyPr>
+          <a:lstStyle/>
+          <a:p>
+            <a:r>
+              <a:rPr lang="zh-CN" altLang="en-US" sz="1300">
+                <a:solidFill>
+                  <a:srgbClr val="172A3A"/>
+                </a:solidFill>
+                <a:latin typeface="Microsoft YaHei" panose="020B0503020204020204" pitchFamily="34" charset="-122"/>
+                <a:ea typeface="Microsoft YaHei" panose="020B0503020204020204" pitchFamily="34" charset="-122"/>
+              </a:rPr>
+              <a:t>找</a:t>
+            </a:r>
+            <a:r>
+              <a:rPr lang="en-US" altLang="zh-CN" sz="1300">
+                <a:solidFill>
+                  <a:srgbClr val="172A3A"/>
+                </a:solidFill>
+                <a:latin typeface="Microsoft YaHei" panose="020B0503020204020204" pitchFamily="34" charset="-122"/>
+                <a:ea typeface="Microsoft YaHei" panose="020B0503020204020204" pitchFamily="34" charset="-122"/>
+              </a:rPr>
+              <a:t>1</a:t>
+            </a:r>
+            <a:r>
+              <a:rPr lang="zh-CN" altLang="en-US" sz="1300">
+                <a:solidFill>
+                  <a:srgbClr val="172A3A"/>
+                </a:solidFill>
+                <a:latin typeface="Microsoft YaHei" panose="020B0503020204020204" pitchFamily="34" charset="-122"/>
+                <a:ea typeface="Microsoft YaHei" panose="020B0503020204020204" pitchFamily="34" charset="-122"/>
+              </a:rPr>
+              <a:t>个核心网点 </a:t>
+            </a:r>
+            <a:r>
+              <a:rPr lang="en-US" altLang="zh-CN" sz="1300">
+                <a:solidFill>
+                  <a:srgbClr val="172A3A"/>
+                </a:solidFill>
+                <a:latin typeface="Microsoft YaHei" panose="020B0503020204020204" pitchFamily="34" charset="-122"/>
+                <a:ea typeface="Microsoft YaHei" panose="020B0503020204020204" pitchFamily="34" charset="-122"/>
+              </a:rPr>
+              <a:t>+ 1</a:t>
+            </a:r>
+            <a:r>
+              <a:rPr lang="zh-CN" altLang="en-US" sz="1300">
+                <a:solidFill>
+                  <a:srgbClr val="172A3A"/>
+                </a:solidFill>
+                <a:latin typeface="Microsoft YaHei" panose="020B0503020204020204" pitchFamily="34" charset="-122"/>
+                <a:ea typeface="Microsoft YaHei" panose="020B0503020204020204" pitchFamily="34" charset="-122"/>
+              </a:rPr>
+              <a:t>个真实项目</a:t>
+            </a:r>
+          </a:p>
+        </p:txBody>
+      </p:sp>
+      <p:sp>
+        <p:nvSpPr>
+          <p:cNvPr id="18" name="ACT_02_OWNER">
+            <a:extLst>
+              <a:ext uri="{FF2B5EF4-FFF2-40B4-BE49-F238E27FC236}">
+                <a16:creationId xmlns:a16="http://schemas.microsoft.com/office/drawing/2014/main" id="{955BE149-8750-C4C9-C3E3-1869F2079AAF}"/>
+              </a:ext>
+            </a:extLst>
+          </p:cNvPr>
+          <p:cNvSpPr txBox="1"/>
+          <p:nvPr/>
+        </p:nvSpPr>
+        <p:spPr>
+          <a:xfrm>
+            <a:off x="6583680" y="3035808"/>
+            <a:ext cx="1554480" cy="369332"/>
+          </a:xfrm>
+          <a:prstGeom prst="rect">
+            <a:avLst/>
+          </a:prstGeom>
+          <a:noFill/>
+        </p:spPr>
+        <p:txBody>
+          <a:bodyPr vert="horz" wrap="square" rtlCol="0">
+            <a:noAutofit/>
+          </a:bodyPr>
+          <a:lstStyle/>
+          <a:p>
+            <a:r>
+              <a:rPr lang="en-US" altLang="zh-CN" sz="1300">
+                <a:solidFill>
+                  <a:srgbClr val="172A3A"/>
+                </a:solidFill>
+                <a:latin typeface="Microsoft YaHei" panose="020B0503020204020204" pitchFamily="34" charset="-122"/>
+                <a:ea typeface="Microsoft YaHei" panose="020B0503020204020204" pitchFamily="34" charset="-122"/>
+              </a:rPr>
+              <a:t>____</a:t>
+            </a:r>
+            <a:endParaRPr lang="zh-CN" altLang="en-US" sz="1300">
+              <a:solidFill>
+                <a:srgbClr val="172A3A"/>
+              </a:solidFill>
+              <a:latin typeface="Microsoft YaHei" panose="020B0503020204020204" pitchFamily="34" charset="-122"/>
+              <a:ea typeface="Microsoft YaHei" panose="020B0503020204020204" pitchFamily="34" charset="-122"/>
+            </a:endParaRPr>
+          </a:p>
+        </p:txBody>
+      </p:sp>
+      <p:sp>
+        <p:nvSpPr>
+          <p:cNvPr id="19" name="ACT_02_DATE">
+            <a:extLst>
+              <a:ext uri="{FF2B5EF4-FFF2-40B4-BE49-F238E27FC236}">
+                <a16:creationId xmlns:a16="http://schemas.microsoft.com/office/drawing/2014/main" id="{4CF664D0-9DD8-2345-0803-62F8E661444E}"/>
+              </a:ext>
+            </a:extLst>
+          </p:cNvPr>
+          <p:cNvSpPr txBox="1"/>
+          <p:nvPr/>
+        </p:nvSpPr>
+        <p:spPr>
+          <a:xfrm>
+            <a:off x="8229600" y="3035808"/>
+            <a:ext cx="1554480" cy="369332"/>
+          </a:xfrm>
+          <a:prstGeom prst="rect">
+            <a:avLst/>
+          </a:prstGeom>
+          <a:noFill/>
+        </p:spPr>
+        <p:txBody>
+          <a:bodyPr vert="horz" wrap="square" rtlCol="0">
+            <a:noAutofit/>
+          </a:bodyPr>
+          <a:lstStyle/>
+          <a:p>
+            <a:r>
+              <a:rPr lang="zh-CN" altLang="en-US" sz="1300">
+                <a:solidFill>
+                  <a:srgbClr val="172A3A"/>
+                </a:solidFill>
+                <a:latin typeface="Microsoft YaHei" panose="020B0503020204020204" pitchFamily="34" charset="-122"/>
+                <a:ea typeface="Microsoft YaHei" panose="020B0503020204020204" pitchFamily="34" charset="-122"/>
+              </a:rPr>
+              <a:t>第</a:t>
+            </a:r>
+            <a:r>
+              <a:rPr lang="en-US" altLang="zh-CN" sz="1300">
+                <a:solidFill>
+                  <a:srgbClr val="172A3A"/>
+                </a:solidFill>
+                <a:latin typeface="Microsoft YaHei" panose="020B0503020204020204" pitchFamily="34" charset="-122"/>
+                <a:ea typeface="Microsoft YaHei" panose="020B0503020204020204" pitchFamily="34" charset="-122"/>
+              </a:rPr>
+              <a:t>1-3</a:t>
+            </a:r>
+            <a:r>
+              <a:rPr lang="zh-CN" altLang="en-US" sz="1300">
+                <a:solidFill>
+                  <a:srgbClr val="172A3A"/>
+                </a:solidFill>
+                <a:latin typeface="Microsoft YaHei" panose="020B0503020204020204" pitchFamily="34" charset="-122"/>
+                <a:ea typeface="Microsoft YaHei" panose="020B0503020204020204" pitchFamily="34" charset="-122"/>
+              </a:rPr>
+              <a:t>周</a:t>
+            </a:r>
+          </a:p>
+        </p:txBody>
+      </p:sp>
+      <p:sp>
+        <p:nvSpPr>
+          <p:cNvPr id="20" name="ACT_02_METRIC">
+            <a:extLst>
+              <a:ext uri="{FF2B5EF4-FFF2-40B4-BE49-F238E27FC236}">
+                <a16:creationId xmlns:a16="http://schemas.microsoft.com/office/drawing/2014/main" id="{DE7D4B0C-725D-41C9-7072-A980A42C9258}"/>
+              </a:ext>
+            </a:extLst>
+          </p:cNvPr>
+          <p:cNvSpPr txBox="1"/>
+          <p:nvPr/>
+        </p:nvSpPr>
+        <p:spPr>
+          <a:xfrm>
+            <a:off x="9921240" y="3035808"/>
+            <a:ext cx="2011680" cy="369332"/>
+          </a:xfrm>
+          <a:prstGeom prst="rect">
+            <a:avLst/>
+          </a:prstGeom>
+          <a:noFill/>
+        </p:spPr>
+        <p:txBody>
+          <a:bodyPr vert="horz" wrap="square" rtlCol="0">
+            <a:noAutofit/>
+          </a:bodyPr>
+          <a:lstStyle/>
+          <a:p>
+            <a:r>
+              <a:rPr lang="zh-CN" altLang="en-US" sz="1300">
+                <a:solidFill>
+                  <a:srgbClr val="172A3A"/>
+                </a:solidFill>
+                <a:latin typeface="Microsoft YaHei" panose="020B0503020204020204" pitchFamily="34" charset="-122"/>
+                <a:ea typeface="Microsoft YaHei" panose="020B0503020204020204" pitchFamily="34" charset="-122"/>
+              </a:rPr>
+              <a:t>完成首批业务</a:t>
+            </a:r>
+          </a:p>
+        </p:txBody>
+      </p:sp>
+      <p:sp>
+        <p:nvSpPr>
+          <p:cNvPr id="21" name="ROW_BAND_3">
+            <a:extLst>
+              <a:ext uri="{FF2B5EF4-FFF2-40B4-BE49-F238E27FC236}">
+                <a16:creationId xmlns:a16="http://schemas.microsoft.com/office/drawing/2014/main" id="{5AB1DE9A-ACF2-CAF1-C9B5-A10BCD12F88E}"/>
+              </a:ext>
+            </a:extLst>
+          </p:cNvPr>
+          <p:cNvSpPr/>
+          <p:nvPr/>
+        </p:nvSpPr>
+        <p:spPr>
+          <a:xfrm>
+            <a:off x="594360" y="3703320"/>
+            <a:ext cx="11155680" cy="822960"/>
+          </a:xfrm>
+          <a:prstGeom prst="rect">
+            <a:avLst/>
+          </a:prstGeom>
+          <a:solidFill>
+            <a:srgbClr val="F0F1EF"/>
+          </a:solidFill>
+          <a:ln w="9525">
+            <a:solidFill>
+              <a:srgbClr val="66747C"/>
+            </a:solidFill>
+          </a:ln>
+        </p:spPr>
+        <p:style>
+          <a:lnRef idx="2">
+            <a:schemeClr val="accent1">
+              <a:shade val="15000"/>
+            </a:schemeClr>
+          </a:lnRef>
+          <a:fillRef idx="1">
+            <a:schemeClr val="accent1"/>
+          </a:fillRef>
+          <a:effectRef idx="0">
+            <a:schemeClr val="accent1"/>
+          </a:effectRef>
+          <a:fontRef idx="minor">
+            <a:schemeClr val="lt1"/>
+          </a:fontRef>
+        </p:style>
+        <p:txBody>
+          <a:bodyPr rtlCol="0" anchor="ctr"/>
+          <a:lstStyle/>
+          <a:p>
+            <a:pPr algn="ctr"/>
+            <a:endParaRPr lang="zh-CN" altLang="en-US"/>
+          </a:p>
+        </p:txBody>
+      </p:sp>
+      <p:sp>
+        <p:nvSpPr>
+          <p:cNvPr id="22" name="ACT_03_OBJECT">
+            <a:extLst>
+              <a:ext uri="{FF2B5EF4-FFF2-40B4-BE49-F238E27FC236}">
+                <a16:creationId xmlns:a16="http://schemas.microsoft.com/office/drawing/2014/main" id="{C0739392-A6A3-7C2A-B977-006B43CA94B5}"/>
+              </a:ext>
+            </a:extLst>
+          </p:cNvPr>
+          <p:cNvSpPr txBox="1"/>
+          <p:nvPr/>
+        </p:nvSpPr>
+        <p:spPr>
+          <a:xfrm>
+            <a:off x="731520" y="3904488"/>
+            <a:ext cx="1737360" cy="369332"/>
+          </a:xfrm>
+          <a:prstGeom prst="rect">
+            <a:avLst/>
+          </a:prstGeom>
+          <a:noFill/>
+        </p:spPr>
+        <p:txBody>
+          <a:bodyPr vert="horz" wrap="square" rtlCol="0">
+            <a:noAutofit/>
+          </a:bodyPr>
+          <a:lstStyle/>
+          <a:p>
+            <a:r>
+              <a:rPr lang="zh-CN" altLang="en-US" sz="1300">
+                <a:solidFill>
+                  <a:srgbClr val="172A3A"/>
+                </a:solidFill>
+                <a:latin typeface="Microsoft YaHei" panose="020B0503020204020204" pitchFamily="34" charset="-122"/>
+                <a:ea typeface="Microsoft YaHei" panose="020B0503020204020204" pitchFamily="34" charset="-122"/>
+              </a:rPr>
+              <a:t>全区域</a:t>
+            </a:r>
+          </a:p>
+        </p:txBody>
+      </p:sp>
+      <p:sp>
+        <p:nvSpPr>
+          <p:cNvPr id="23" name="ACT_03_ACTION">
+            <a:extLst>
+              <a:ext uri="{FF2B5EF4-FFF2-40B4-BE49-F238E27FC236}">
+                <a16:creationId xmlns:a16="http://schemas.microsoft.com/office/drawing/2014/main" id="{19E4104F-62EB-BC13-756C-21A7D3BCCD65}"/>
+              </a:ext>
+            </a:extLst>
+          </p:cNvPr>
+          <p:cNvSpPr txBox="1"/>
+          <p:nvPr/>
+        </p:nvSpPr>
+        <p:spPr>
+          <a:xfrm>
+            <a:off x="2606040" y="3904488"/>
+            <a:ext cx="3840480" cy="369332"/>
+          </a:xfrm>
+          <a:prstGeom prst="rect">
+            <a:avLst/>
+          </a:prstGeom>
+          <a:noFill/>
+        </p:spPr>
+        <p:txBody>
+          <a:bodyPr vert="horz" wrap="square" rtlCol="0">
+            <a:noAutofit/>
+          </a:bodyPr>
+          <a:lstStyle/>
+          <a:p>
+            <a:r>
+              <a:rPr lang="zh-CN" altLang="en-US" sz="1300">
+                <a:solidFill>
+                  <a:srgbClr val="172A3A"/>
+                </a:solidFill>
+                <a:latin typeface="Microsoft YaHei" panose="020B0503020204020204" pitchFamily="34" charset="-122"/>
+                <a:ea typeface="Microsoft YaHei" panose="020B0503020204020204" pitchFamily="34" charset="-122"/>
+              </a:rPr>
+              <a:t>盘点旧房翻修</a:t>
+            </a:r>
+            <a:r>
+              <a:rPr lang="en-US" altLang="zh-CN" sz="1300">
+                <a:solidFill>
+                  <a:srgbClr val="172A3A"/>
+                </a:solidFill>
+                <a:latin typeface="Microsoft YaHei" panose="020B0503020204020204" pitchFamily="34" charset="-122"/>
+                <a:ea typeface="Microsoft YaHei" panose="020B0503020204020204" pitchFamily="34" charset="-122"/>
+              </a:rPr>
+              <a:t>/</a:t>
+            </a:r>
+            <a:r>
+              <a:rPr lang="zh-CN" altLang="en-US" sz="1300">
+                <a:solidFill>
+                  <a:srgbClr val="172A3A"/>
+                </a:solidFill>
+                <a:latin typeface="Microsoft YaHei" panose="020B0503020204020204" pitchFamily="34" charset="-122"/>
+                <a:ea typeface="Microsoft YaHei" panose="020B0503020204020204" pitchFamily="34" charset="-122"/>
+              </a:rPr>
+              <a:t>漏水维修线索</a:t>
+            </a:r>
+          </a:p>
+        </p:txBody>
+      </p:sp>
+      <p:sp>
+        <p:nvSpPr>
+          <p:cNvPr id="24" name="ACT_03_OWNER">
+            <a:extLst>
+              <a:ext uri="{FF2B5EF4-FFF2-40B4-BE49-F238E27FC236}">
+                <a16:creationId xmlns:a16="http://schemas.microsoft.com/office/drawing/2014/main" id="{0518CA2B-93CE-A458-FF90-898AABA98595}"/>
+              </a:ext>
+            </a:extLst>
+          </p:cNvPr>
+          <p:cNvSpPr txBox="1"/>
+          <p:nvPr/>
+        </p:nvSpPr>
+        <p:spPr>
+          <a:xfrm>
+            <a:off x="6583680" y="3904488"/>
+            <a:ext cx="1554480" cy="369332"/>
+          </a:xfrm>
+          <a:prstGeom prst="rect">
+            <a:avLst/>
+          </a:prstGeom>
+          <a:noFill/>
+        </p:spPr>
+        <p:txBody>
+          <a:bodyPr vert="horz" wrap="square" rtlCol="0">
+            <a:noAutofit/>
+          </a:bodyPr>
+          <a:lstStyle/>
+          <a:p>
+            <a:r>
+              <a:rPr lang="en-US" altLang="zh-CN" sz="1300">
+                <a:solidFill>
+                  <a:srgbClr val="172A3A"/>
+                </a:solidFill>
+                <a:latin typeface="Microsoft YaHei" panose="020B0503020204020204" pitchFamily="34" charset="-122"/>
+                <a:ea typeface="Microsoft YaHei" panose="020B0503020204020204" pitchFamily="34" charset="-122"/>
+              </a:rPr>
+              <a:t>____</a:t>
+            </a:r>
+            <a:endParaRPr lang="zh-CN" altLang="en-US" sz="1300">
+              <a:solidFill>
+                <a:srgbClr val="172A3A"/>
+              </a:solidFill>
+              <a:latin typeface="Microsoft YaHei" panose="020B0503020204020204" pitchFamily="34" charset="-122"/>
+              <a:ea typeface="Microsoft YaHei" panose="020B0503020204020204" pitchFamily="34" charset="-122"/>
+            </a:endParaRPr>
+          </a:p>
+        </p:txBody>
+      </p:sp>
+      <p:sp>
+        <p:nvSpPr>
+          <p:cNvPr id="25" name="ACT_03_DATE">
+            <a:extLst>
+              <a:ext uri="{FF2B5EF4-FFF2-40B4-BE49-F238E27FC236}">
+                <a16:creationId xmlns:a16="http://schemas.microsoft.com/office/drawing/2014/main" id="{680635C2-C852-4268-9158-476B1365D8A7}"/>
+              </a:ext>
+            </a:extLst>
+          </p:cNvPr>
+          <p:cNvSpPr txBox="1"/>
+          <p:nvPr/>
+        </p:nvSpPr>
+        <p:spPr>
+          <a:xfrm>
+            <a:off x="8229600" y="3904488"/>
+            <a:ext cx="1554480" cy="369332"/>
+          </a:xfrm>
+          <a:prstGeom prst="rect">
+            <a:avLst/>
+          </a:prstGeom>
+          <a:noFill/>
+        </p:spPr>
+        <p:txBody>
+          <a:bodyPr vert="horz" wrap="square" rtlCol="0">
+            <a:noAutofit/>
+          </a:bodyPr>
+          <a:lstStyle/>
+          <a:p>
+            <a:r>
+              <a:rPr lang="zh-CN" altLang="en-US" sz="1300">
+                <a:solidFill>
+                  <a:srgbClr val="172A3A"/>
+                </a:solidFill>
+                <a:latin typeface="Microsoft YaHei" panose="020B0503020204020204" pitchFamily="34" charset="-122"/>
+                <a:ea typeface="Microsoft YaHei" panose="020B0503020204020204" pitchFamily="34" charset="-122"/>
+              </a:rPr>
+              <a:t>第</a:t>
+            </a:r>
+            <a:r>
+              <a:rPr lang="en-US" altLang="zh-CN" sz="1300">
+                <a:solidFill>
+                  <a:srgbClr val="172A3A"/>
+                </a:solidFill>
+                <a:latin typeface="Microsoft YaHei" panose="020B0503020204020204" pitchFamily="34" charset="-122"/>
+                <a:ea typeface="Microsoft YaHei" panose="020B0503020204020204" pitchFamily="34" charset="-122"/>
+              </a:rPr>
+              <a:t>2</a:t>
+            </a:r>
+            <a:r>
+              <a:rPr lang="zh-CN" altLang="en-US" sz="1300">
+                <a:solidFill>
+                  <a:srgbClr val="172A3A"/>
+                </a:solidFill>
+                <a:latin typeface="Microsoft YaHei" panose="020B0503020204020204" pitchFamily="34" charset="-122"/>
+                <a:ea typeface="Microsoft YaHei" panose="020B0503020204020204" pitchFamily="34" charset="-122"/>
+              </a:rPr>
+              <a:t>周</a:t>
+            </a:r>
+          </a:p>
+        </p:txBody>
+      </p:sp>
+      <p:sp>
+        <p:nvSpPr>
+          <p:cNvPr id="26" name="ACT_03_METRIC">
+            <a:extLst>
+              <a:ext uri="{FF2B5EF4-FFF2-40B4-BE49-F238E27FC236}">
+                <a16:creationId xmlns:a16="http://schemas.microsoft.com/office/drawing/2014/main" id="{E870A316-96BC-DA7A-6CFC-0307EB96123F}"/>
+              </a:ext>
+            </a:extLst>
+          </p:cNvPr>
+          <p:cNvSpPr txBox="1"/>
+          <p:nvPr/>
+        </p:nvSpPr>
+        <p:spPr>
+          <a:xfrm>
+            <a:off x="9921240" y="3904488"/>
+            <a:ext cx="2011680" cy="369332"/>
+          </a:xfrm>
+          <a:prstGeom prst="rect">
+            <a:avLst/>
+          </a:prstGeom>
+          <a:noFill/>
+        </p:spPr>
+        <p:txBody>
+          <a:bodyPr vert="horz" wrap="square" rtlCol="0">
+            <a:noAutofit/>
+          </a:bodyPr>
+          <a:lstStyle/>
+          <a:p>
+            <a:r>
+              <a:rPr lang="zh-CN" altLang="en-US" sz="1300">
+                <a:solidFill>
+                  <a:srgbClr val="172A3A"/>
+                </a:solidFill>
+                <a:latin typeface="Microsoft YaHei" panose="020B0503020204020204" pitchFamily="34" charset="-122"/>
+                <a:ea typeface="Microsoft YaHei" panose="020B0503020204020204" pitchFamily="34" charset="-122"/>
+              </a:rPr>
+              <a:t>线索清单≥</a:t>
+            </a:r>
+            <a:r>
+              <a:rPr lang="en-US" altLang="zh-CN" sz="1300">
+                <a:solidFill>
+                  <a:srgbClr val="172A3A"/>
+                </a:solidFill>
+                <a:latin typeface="Microsoft YaHei" panose="020B0503020204020204" pitchFamily="34" charset="-122"/>
+                <a:ea typeface="Microsoft YaHei" panose="020B0503020204020204" pitchFamily="34" charset="-122"/>
+              </a:rPr>
+              <a:t>10</a:t>
+            </a:r>
+            <a:r>
+              <a:rPr lang="zh-CN" altLang="en-US" sz="1300">
+                <a:solidFill>
+                  <a:srgbClr val="172A3A"/>
+                </a:solidFill>
+                <a:latin typeface="Microsoft YaHei" panose="020B0503020204020204" pitchFamily="34" charset="-122"/>
+                <a:ea typeface="Microsoft YaHei" panose="020B0503020204020204" pitchFamily="34" charset="-122"/>
+              </a:rPr>
+              <a:t>条</a:t>
+            </a:r>
+          </a:p>
+        </p:txBody>
+      </p:sp>
+      <p:sp>
+        <p:nvSpPr>
+          <p:cNvPr id="27" name="ROW_BAND_4">
+            <a:extLst>
+              <a:ext uri="{FF2B5EF4-FFF2-40B4-BE49-F238E27FC236}">
+                <a16:creationId xmlns:a16="http://schemas.microsoft.com/office/drawing/2014/main" id="{9ABC7208-5992-CD0E-6BF1-AFA849EAC77A}"/>
+              </a:ext>
+            </a:extLst>
+          </p:cNvPr>
+          <p:cNvSpPr/>
+          <p:nvPr/>
+        </p:nvSpPr>
+        <p:spPr>
+          <a:xfrm>
+            <a:off x="594360" y="4572000"/>
+            <a:ext cx="11155680" cy="822960"/>
+          </a:xfrm>
+          <a:prstGeom prst="rect">
+            <a:avLst/>
+          </a:prstGeom>
+          <a:solidFill>
+            <a:srgbClr val="F7E6E6"/>
+          </a:solidFill>
+          <a:ln w="9525">
+            <a:solidFill>
+              <a:srgbClr val="66747C"/>
+            </a:solidFill>
+          </a:ln>
+        </p:spPr>
+        <p:style>
+          <a:lnRef idx="2">
+            <a:schemeClr val="accent1">
+              <a:shade val="15000"/>
+            </a:schemeClr>
+          </a:lnRef>
+          <a:fillRef idx="1">
+            <a:schemeClr val="accent1"/>
+          </a:fillRef>
+          <a:effectRef idx="0">
+            <a:schemeClr val="accent1"/>
+          </a:effectRef>
+          <a:fontRef idx="minor">
+            <a:schemeClr val="lt1"/>
+          </a:fontRef>
+        </p:style>
+        <p:txBody>
+          <a:bodyPr rtlCol="0" anchor="ctr"/>
+          <a:lstStyle/>
+          <a:p>
+            <a:pPr algn="ctr"/>
+            <a:endParaRPr lang="zh-CN" altLang="en-US"/>
+          </a:p>
+        </p:txBody>
+      </p:sp>
+      <p:sp>
+        <p:nvSpPr>
+          <p:cNvPr id="28" name="ACT_04_OBJECT">
+            <a:extLst>
+              <a:ext uri="{FF2B5EF4-FFF2-40B4-BE49-F238E27FC236}">
+                <a16:creationId xmlns:a16="http://schemas.microsoft.com/office/drawing/2014/main" id="{C6C1D7FE-C4EE-81F2-02D2-B37629AC0CA0}"/>
+              </a:ext>
+            </a:extLst>
+          </p:cNvPr>
+          <p:cNvSpPr txBox="1"/>
+          <p:nvPr/>
+        </p:nvSpPr>
+        <p:spPr>
+          <a:xfrm>
+            <a:off x="731520" y="4773168"/>
+            <a:ext cx="1737360" cy="369332"/>
+          </a:xfrm>
+          <a:prstGeom prst="rect">
+            <a:avLst/>
+          </a:prstGeom>
+          <a:noFill/>
+        </p:spPr>
+        <p:txBody>
+          <a:bodyPr vert="horz" wrap="square" rtlCol="0">
+            <a:noAutofit/>
+          </a:bodyPr>
+          <a:lstStyle/>
+          <a:p>
+            <a:r>
+              <a:rPr lang="zh-CN" altLang="en-US" sz="1300">
+                <a:solidFill>
+                  <a:srgbClr val="172A3A"/>
+                </a:solidFill>
+                <a:latin typeface="Microsoft YaHei" panose="020B0503020204020204" pitchFamily="34" charset="-122"/>
+                <a:ea typeface="Microsoft YaHei" panose="020B0503020204020204" pitchFamily="34" charset="-122"/>
+              </a:rPr>
+              <a:t>品牌沉淀</a:t>
+            </a:r>
+          </a:p>
+        </p:txBody>
+      </p:sp>
+      <p:sp>
+        <p:nvSpPr>
+          <p:cNvPr id="29" name="ACT_04_ACTION">
+            <a:extLst>
+              <a:ext uri="{FF2B5EF4-FFF2-40B4-BE49-F238E27FC236}">
+                <a16:creationId xmlns:a16="http://schemas.microsoft.com/office/drawing/2014/main" id="{53A36BB2-06CD-751C-12CC-413C419861FE}"/>
+              </a:ext>
+            </a:extLst>
+          </p:cNvPr>
+          <p:cNvSpPr txBox="1"/>
+          <p:nvPr/>
+        </p:nvSpPr>
+        <p:spPr>
+          <a:xfrm>
+            <a:off x="2606040" y="4773168"/>
+            <a:ext cx="3840480" cy="369332"/>
+          </a:xfrm>
+          <a:prstGeom prst="rect">
+            <a:avLst/>
+          </a:prstGeom>
+          <a:noFill/>
+        </p:spPr>
+        <p:txBody>
+          <a:bodyPr vert="horz" wrap="square" rtlCol="0">
+            <a:noAutofit/>
+          </a:bodyPr>
+          <a:lstStyle/>
+          <a:p>
+            <a:r>
+              <a:rPr lang="en-US" altLang="zh-CN" sz="1300">
+                <a:solidFill>
+                  <a:srgbClr val="172A3A"/>
+                </a:solidFill>
+                <a:latin typeface="Microsoft YaHei" panose="020B0503020204020204" pitchFamily="34" charset="-122"/>
+                <a:ea typeface="Microsoft YaHei" panose="020B0503020204020204" pitchFamily="34" charset="-122"/>
+              </a:rPr>
+              <a:t>1</a:t>
+            </a:r>
+            <a:r>
+              <a:rPr lang="zh-CN" altLang="en-US" sz="1300">
+                <a:solidFill>
+                  <a:srgbClr val="172A3A"/>
+                </a:solidFill>
+                <a:latin typeface="Microsoft YaHei" panose="020B0503020204020204" pitchFamily="34" charset="-122"/>
+                <a:ea typeface="Microsoft YaHei" panose="020B0503020204020204" pitchFamily="34" charset="-122"/>
+              </a:rPr>
+              <a:t>个样板项目整理照片与推荐</a:t>
+            </a:r>
+          </a:p>
+        </p:txBody>
+      </p:sp>
+      <p:sp>
+        <p:nvSpPr>
+          <p:cNvPr id="30" name="ACT_04_OWNER">
+            <a:extLst>
+              <a:ext uri="{FF2B5EF4-FFF2-40B4-BE49-F238E27FC236}">
+                <a16:creationId xmlns:a16="http://schemas.microsoft.com/office/drawing/2014/main" id="{D2D885C9-1138-7797-4175-D9EA483C33EA}"/>
+              </a:ext>
+            </a:extLst>
+          </p:cNvPr>
+          <p:cNvSpPr txBox="1"/>
+          <p:nvPr/>
+        </p:nvSpPr>
+        <p:spPr>
+          <a:xfrm>
+            <a:off x="6583680" y="4773168"/>
+            <a:ext cx="1554480" cy="369332"/>
+          </a:xfrm>
+          <a:prstGeom prst="rect">
+            <a:avLst/>
+          </a:prstGeom>
+          <a:noFill/>
+        </p:spPr>
+        <p:txBody>
+          <a:bodyPr vert="horz" wrap="square" rtlCol="0">
+            <a:noAutofit/>
+          </a:bodyPr>
+          <a:lstStyle/>
+          <a:p>
+            <a:r>
+              <a:rPr lang="en-US" altLang="zh-CN" sz="1300">
+                <a:solidFill>
+                  <a:srgbClr val="172A3A"/>
+                </a:solidFill>
+                <a:latin typeface="Microsoft YaHei" panose="020B0503020204020204" pitchFamily="34" charset="-122"/>
+                <a:ea typeface="Microsoft YaHei" panose="020B0503020204020204" pitchFamily="34" charset="-122"/>
+              </a:rPr>
+              <a:t>____</a:t>
+            </a:r>
+            <a:endParaRPr lang="zh-CN" altLang="en-US" sz="1300">
+              <a:solidFill>
+                <a:srgbClr val="172A3A"/>
+              </a:solidFill>
+              <a:latin typeface="Microsoft YaHei" panose="020B0503020204020204" pitchFamily="34" charset="-122"/>
+              <a:ea typeface="Microsoft YaHei" panose="020B0503020204020204" pitchFamily="34" charset="-122"/>
+            </a:endParaRPr>
+          </a:p>
+        </p:txBody>
+      </p:sp>
+      <p:sp>
+        <p:nvSpPr>
+          <p:cNvPr id="31" name="ACT_04_DATE">
+            <a:extLst>
+              <a:ext uri="{FF2B5EF4-FFF2-40B4-BE49-F238E27FC236}">
+                <a16:creationId xmlns:a16="http://schemas.microsoft.com/office/drawing/2014/main" id="{E3486880-9BF6-E87F-77B7-272834862148}"/>
+              </a:ext>
+            </a:extLst>
+          </p:cNvPr>
+          <p:cNvSpPr txBox="1"/>
+          <p:nvPr/>
+        </p:nvSpPr>
+        <p:spPr>
+          <a:xfrm>
+            <a:off x="8229600" y="4773168"/>
+            <a:ext cx="1554480" cy="369332"/>
+          </a:xfrm>
+          <a:prstGeom prst="rect">
+            <a:avLst/>
+          </a:prstGeom>
+          <a:noFill/>
+        </p:spPr>
+        <p:txBody>
+          <a:bodyPr vert="horz" wrap="square" rtlCol="0">
+            <a:noAutofit/>
+          </a:bodyPr>
+          <a:lstStyle/>
+          <a:p>
+            <a:r>
+              <a:rPr lang="zh-CN" altLang="en-US" sz="1300">
+                <a:solidFill>
+                  <a:srgbClr val="172A3A"/>
+                </a:solidFill>
+                <a:latin typeface="Microsoft YaHei" panose="020B0503020204020204" pitchFamily="34" charset="-122"/>
+                <a:ea typeface="Microsoft YaHei" panose="020B0503020204020204" pitchFamily="34" charset="-122"/>
+              </a:rPr>
+              <a:t>第</a:t>
+            </a:r>
+            <a:r>
+              <a:rPr lang="en-US" altLang="zh-CN" sz="1300">
+                <a:solidFill>
+                  <a:srgbClr val="172A3A"/>
+                </a:solidFill>
+                <a:latin typeface="Microsoft YaHei" panose="020B0503020204020204" pitchFamily="34" charset="-122"/>
+                <a:ea typeface="Microsoft YaHei" panose="020B0503020204020204" pitchFamily="34" charset="-122"/>
+              </a:rPr>
+              <a:t>3-4</a:t>
+            </a:r>
+            <a:r>
+              <a:rPr lang="zh-CN" altLang="en-US" sz="1300">
+                <a:solidFill>
+                  <a:srgbClr val="172A3A"/>
+                </a:solidFill>
+                <a:latin typeface="Microsoft YaHei" panose="020B0503020204020204" pitchFamily="34" charset="-122"/>
+                <a:ea typeface="Microsoft YaHei" panose="020B0503020204020204" pitchFamily="34" charset="-122"/>
+              </a:rPr>
+              <a:t>周</a:t>
+            </a:r>
+          </a:p>
+        </p:txBody>
+      </p:sp>
+      <p:sp>
+        <p:nvSpPr>
+          <p:cNvPr id="32" name="ACT_04_METRIC">
+            <a:extLst>
+              <a:ext uri="{FF2B5EF4-FFF2-40B4-BE49-F238E27FC236}">
+                <a16:creationId xmlns:a16="http://schemas.microsoft.com/office/drawing/2014/main" id="{AA140A7B-5EE9-39E5-79FE-F57D3DFF28EC}"/>
+              </a:ext>
+            </a:extLst>
+          </p:cNvPr>
+          <p:cNvSpPr txBox="1"/>
+          <p:nvPr/>
+        </p:nvSpPr>
+        <p:spPr>
+          <a:xfrm>
+            <a:off x="9921240" y="4773168"/>
+            <a:ext cx="2011680" cy="369332"/>
+          </a:xfrm>
+          <a:prstGeom prst="rect">
+            <a:avLst/>
+          </a:prstGeom>
+          <a:noFill/>
+        </p:spPr>
+        <p:txBody>
+          <a:bodyPr vert="horz" wrap="square" rtlCol="0">
+            <a:noAutofit/>
+          </a:bodyPr>
+          <a:lstStyle/>
+          <a:p>
+            <a:r>
+              <a:rPr lang="zh-CN" altLang="en-US" sz="1300">
+                <a:solidFill>
+                  <a:srgbClr val="172A3A"/>
+                </a:solidFill>
+                <a:latin typeface="Microsoft YaHei" panose="020B0503020204020204" pitchFamily="34" charset="-122"/>
+                <a:ea typeface="Microsoft YaHei" panose="020B0503020204020204" pitchFamily="34" charset="-122"/>
+              </a:rPr>
+              <a:t>样板照片</a:t>
+            </a:r>
+            <a:r>
+              <a:rPr lang="en-US" altLang="zh-CN" sz="1300">
+                <a:solidFill>
+                  <a:srgbClr val="172A3A"/>
+                </a:solidFill>
+                <a:latin typeface="Microsoft YaHei" panose="020B0503020204020204" pitchFamily="34" charset="-122"/>
+                <a:ea typeface="Microsoft YaHei" panose="020B0503020204020204" pitchFamily="34" charset="-122"/>
+              </a:rPr>
+              <a:t>+</a:t>
+            </a:r>
+            <a:r>
+              <a:rPr lang="zh-CN" altLang="en-US" sz="1300">
+                <a:solidFill>
+                  <a:srgbClr val="172A3A"/>
+                </a:solidFill>
+                <a:latin typeface="Microsoft YaHei" panose="020B0503020204020204" pitchFamily="34" charset="-122"/>
+                <a:ea typeface="Microsoft YaHei" panose="020B0503020204020204" pitchFamily="34" charset="-122"/>
+              </a:rPr>
+              <a:t>推荐≥</a:t>
+            </a:r>
+            <a:r>
+              <a:rPr lang="en-US" altLang="zh-CN" sz="1300">
+                <a:solidFill>
+                  <a:srgbClr val="172A3A"/>
+                </a:solidFill>
+                <a:latin typeface="Microsoft YaHei" panose="020B0503020204020204" pitchFamily="34" charset="-122"/>
+                <a:ea typeface="Microsoft YaHei" panose="020B0503020204020204" pitchFamily="34" charset="-122"/>
+              </a:rPr>
+              <a:t>3</a:t>
+            </a:r>
+            <a:endParaRPr lang="zh-CN" altLang="en-US" sz="1300">
+              <a:solidFill>
+                <a:srgbClr val="172A3A"/>
+              </a:solidFill>
+              <a:latin typeface="Microsoft YaHei" panose="020B0503020204020204" pitchFamily="34" charset="-122"/>
+              <a:ea typeface="Microsoft YaHei" panose="020B0503020204020204" pitchFamily="34" charset="-122"/>
+            </a:endParaRPr>
+          </a:p>
+        </p:txBody>
+      </p:sp>
+      <p:sp>
+        <p:nvSpPr>
+          <p:cNvPr id="33" name="TEACHING_CUE">
+            <a:extLst>
+              <a:ext uri="{FF2B5EF4-FFF2-40B4-BE49-F238E27FC236}">
+                <a16:creationId xmlns:a16="http://schemas.microsoft.com/office/drawing/2014/main" id="{D197A33E-186C-9514-EB8B-6044E8C02DB0}"/>
+              </a:ext>
+            </a:extLst>
+          </p:cNvPr>
+          <p:cNvSpPr txBox="1"/>
+          <p:nvPr/>
+        </p:nvSpPr>
+        <p:spPr>
+          <a:xfrm>
+            <a:off x="548640" y="5806440"/>
+            <a:ext cx="11064240" cy="369332"/>
+          </a:xfrm>
+          <a:prstGeom prst="rect">
+            <a:avLst/>
+          </a:prstGeom>
+          <a:noFill/>
+        </p:spPr>
+        <p:txBody>
+          <a:bodyPr vert="horz" wrap="square" rtlCol="0">
+            <a:noAutofit/>
+          </a:bodyPr>
+          <a:lstStyle/>
+          <a:p>
+            <a:r>
+              <a:rPr lang="zh-CN" altLang="en-US" sz="1200">
+                <a:solidFill>
+                  <a:srgbClr val="66747C"/>
+                </a:solidFill>
+                <a:latin typeface="Microsoft YaHei" panose="020B0503020204020204" pitchFamily="34" charset="-122"/>
+                <a:ea typeface="Microsoft YaHei" panose="020B0503020204020204" pitchFamily="34" charset="-122"/>
+              </a:rPr>
+              <a:t>行动必须连接前面诊断出的短板或机会；每项都要能检查，最多选 </a:t>
+            </a:r>
+            <a:r>
+              <a:rPr lang="en-US" altLang="zh-CN" sz="1200">
+                <a:solidFill>
+                  <a:srgbClr val="66747C"/>
+                </a:solidFill>
+                <a:latin typeface="Microsoft YaHei" panose="020B0503020204020204" pitchFamily="34" charset="-122"/>
+                <a:ea typeface="Microsoft YaHei" panose="020B0503020204020204" pitchFamily="34" charset="-122"/>
+              </a:rPr>
+              <a:t>3 </a:t>
+            </a:r>
+            <a:r>
+              <a:rPr lang="zh-CN" altLang="en-US" sz="1200">
+                <a:solidFill>
+                  <a:srgbClr val="66747C"/>
+                </a:solidFill>
+                <a:latin typeface="Microsoft YaHei" panose="020B0503020204020204" pitchFamily="34" charset="-122"/>
+                <a:ea typeface="Microsoft YaHei" panose="020B0503020204020204" pitchFamily="34" charset="-122"/>
+              </a:rPr>
+              <a:t>项最重要的。</a:t>
             </a:r>
           </a:p>
         </p:txBody>
@@ -8355,7 +9854,7 @@
     </p:spTree>
     <p:extLst>
       <p:ext uri="{BB962C8B-B14F-4D97-AF65-F5344CB8AC3E}">
-        <p14:creationId xmlns:p14="http://schemas.microsoft.com/office/powerpoint/2010/main" val="2389771360"/>
+        <p14:creationId xmlns:p14="http://schemas.microsoft.com/office/powerpoint/2010/main" val="652020401"/>
       </p:ext>
     </p:extLst>
   </p:cSld>
@@ -8387,7 +9886,412 @@
           <p:cNvPr id="2" name="文本框 1">
             <a:extLst>
               <a:ext uri="{FF2B5EF4-FFF2-40B4-BE49-F238E27FC236}">
-                <a16:creationId xmlns:a16="http://schemas.microsoft.com/office/drawing/2014/main" id="{7D2DF9FF-AEDA-94C2-279C-94C6D1BA15B7}"/>
+                <a16:creationId xmlns:a16="http://schemas.microsoft.com/office/drawing/2014/main" id="{95805162-1D1D-B5DB-0478-BF5B96F6B051}"/>
+              </a:ext>
+            </a:extLst>
+          </p:cNvPr>
+          <p:cNvSpPr txBox="1"/>
+          <p:nvPr/>
+        </p:nvSpPr>
+        <p:spPr>
+          <a:xfrm>
+            <a:off x="548640" y="384048"/>
+            <a:ext cx="11064240" cy="369332"/>
+          </a:xfrm>
+          <a:prstGeom prst="rect">
+            <a:avLst/>
+          </a:prstGeom>
+          <a:noFill/>
+        </p:spPr>
+        <p:txBody>
+          <a:bodyPr vert="horz" wrap="square" rtlCol="0">
+            <a:noAutofit/>
+          </a:bodyPr>
+          <a:lstStyle/>
+          <a:p>
+            <a:r>
+              <a:rPr lang="zh-CN" altLang="en-US" sz="2600" b="1">
+                <a:solidFill>
+                  <a:srgbClr val="172A3A"/>
+                </a:solidFill>
+                <a:latin typeface="Microsoft YaHei" panose="020B0503020204020204" pitchFamily="34" charset="-122"/>
+                <a:ea typeface="Microsoft YaHei" panose="020B0503020204020204" pitchFamily="34" charset="-122"/>
+              </a:rPr>
+              <a:t>课后作业：画出你的县域生意版图</a:t>
+            </a:r>
+          </a:p>
+        </p:txBody>
+      </p:sp>
+      <p:sp>
+        <p:nvSpPr>
+          <p:cNvPr id="3" name="文本框 2">
+            <a:extLst>
+              <a:ext uri="{FF2B5EF4-FFF2-40B4-BE49-F238E27FC236}">
+                <a16:creationId xmlns:a16="http://schemas.microsoft.com/office/drawing/2014/main" id="{F4C6A9C6-AB13-6EC9-8E85-DAC4B4772A8E}"/>
+              </a:ext>
+            </a:extLst>
+          </p:cNvPr>
+          <p:cNvSpPr txBox="1"/>
+          <p:nvPr/>
+        </p:nvSpPr>
+        <p:spPr>
+          <a:xfrm>
+            <a:off x="640080" y="1463040"/>
+            <a:ext cx="6217920" cy="369332"/>
+          </a:xfrm>
+          <a:prstGeom prst="rect">
+            <a:avLst/>
+          </a:prstGeom>
+          <a:noFill/>
+        </p:spPr>
+        <p:txBody>
+          <a:bodyPr vert="horz" wrap="square" rtlCol="0">
+            <a:noAutofit/>
+          </a:bodyPr>
+          <a:lstStyle/>
+          <a:p>
+            <a:r>
+              <a:rPr lang="zh-CN" altLang="en-US" sz="1700" b="1">
+                <a:solidFill>
+                  <a:srgbClr val="C61720"/>
+                </a:solidFill>
+                <a:latin typeface="Microsoft YaHei" panose="020B0503020204020204" pitchFamily="34" charset="-122"/>
+                <a:ea typeface="Microsoft YaHei" panose="020B0503020204020204" pitchFamily="34" charset="-122"/>
+              </a:rPr>
+              <a:t>作业五步</a:t>
+            </a:r>
+          </a:p>
+        </p:txBody>
+      </p:sp>
+      <p:sp>
+        <p:nvSpPr>
+          <p:cNvPr id="4" name="文本框 3">
+            <a:extLst>
+              <a:ext uri="{FF2B5EF4-FFF2-40B4-BE49-F238E27FC236}">
+                <a16:creationId xmlns:a16="http://schemas.microsoft.com/office/drawing/2014/main" id="{2A8BEB12-76B8-18F3-0515-11CC25E2E626}"/>
+              </a:ext>
+            </a:extLst>
+          </p:cNvPr>
+          <p:cNvSpPr txBox="1"/>
+          <p:nvPr/>
+        </p:nvSpPr>
+        <p:spPr>
+          <a:xfrm>
+            <a:off x="640080" y="2057400"/>
+            <a:ext cx="6217920" cy="369332"/>
+          </a:xfrm>
+          <a:prstGeom prst="rect">
+            <a:avLst/>
+          </a:prstGeom>
+          <a:noFill/>
+        </p:spPr>
+        <p:txBody>
+          <a:bodyPr vert="horz" wrap="square" rtlCol="0">
+            <a:noAutofit/>
+          </a:bodyPr>
+          <a:lstStyle/>
+          <a:p>
+            <a:pPr>
+              <a:lnSpc>
+                <a:spcPct val="140000"/>
+              </a:lnSpc>
+            </a:pPr>
+            <a:r>
+              <a:rPr lang="en-US" altLang="zh-CN" sz="1400">
+                <a:solidFill>
+                  <a:srgbClr val="172A3A"/>
+                </a:solidFill>
+                <a:latin typeface="Microsoft YaHei" panose="020B0503020204020204" pitchFamily="34" charset="-122"/>
+                <a:ea typeface="Microsoft YaHei" panose="020B0503020204020204" pitchFamily="34" charset="-122"/>
+              </a:rPr>
+              <a:t>1. </a:t>
+            </a:r>
+            <a:r>
+              <a:rPr lang="zh-CN" altLang="en-US" sz="1400">
+                <a:solidFill>
+                  <a:srgbClr val="172A3A"/>
+                </a:solidFill>
+                <a:latin typeface="Microsoft YaHei" panose="020B0503020204020204" pitchFamily="34" charset="-122"/>
+                <a:ea typeface="Microsoft YaHei" panose="020B0503020204020204" pitchFamily="34" charset="-122"/>
+              </a:rPr>
+              <a:t>标出县城和主要乡镇</a:t>
+            </a:r>
+          </a:p>
+          <a:p>
+            <a:pPr>
+              <a:lnSpc>
+                <a:spcPct val="140000"/>
+              </a:lnSpc>
+            </a:pPr>
+            <a:r>
+              <a:rPr lang="en-US" altLang="zh-CN" sz="1400">
+                <a:solidFill>
+                  <a:srgbClr val="172A3A"/>
+                </a:solidFill>
+                <a:latin typeface="Microsoft YaHei" panose="020B0503020204020204" pitchFamily="34" charset="-122"/>
+                <a:ea typeface="Microsoft YaHei" panose="020B0503020204020204" pitchFamily="34" charset="-122"/>
+              </a:rPr>
+              <a:t>2. </a:t>
+            </a:r>
+            <a:r>
+              <a:rPr lang="zh-CN" altLang="en-US" sz="1400">
+                <a:solidFill>
+                  <a:srgbClr val="172A3A"/>
+                </a:solidFill>
+                <a:latin typeface="Microsoft YaHei" panose="020B0503020204020204" pitchFamily="34" charset="-122"/>
+                <a:ea typeface="Microsoft YaHei" panose="020B0503020204020204" pitchFamily="34" charset="-122"/>
+              </a:rPr>
+              <a:t>判断各乡镇属于「进得去、站得住、卖得动、做得深」中的哪种状态</a:t>
+            </a:r>
+          </a:p>
+          <a:p>
+            <a:pPr>
+              <a:lnSpc>
+                <a:spcPct val="140000"/>
+              </a:lnSpc>
+            </a:pPr>
+            <a:r>
+              <a:rPr lang="en-US" altLang="zh-CN" sz="1400">
+                <a:solidFill>
+                  <a:srgbClr val="172A3A"/>
+                </a:solidFill>
+                <a:latin typeface="Microsoft YaHei" panose="020B0503020204020204" pitchFamily="34" charset="-122"/>
+                <a:ea typeface="Microsoft YaHei" panose="020B0503020204020204" pitchFamily="34" charset="-122"/>
+              </a:rPr>
+              <a:t>3. </a:t>
+            </a:r>
+            <a:r>
+              <a:rPr lang="zh-CN" altLang="en-US" sz="1400">
+                <a:solidFill>
+                  <a:srgbClr val="172A3A"/>
+                </a:solidFill>
+                <a:latin typeface="Microsoft YaHei" panose="020B0503020204020204" pitchFamily="34" charset="-122"/>
+                <a:ea typeface="Microsoft YaHei" panose="020B0503020204020204" pitchFamily="34" charset="-122"/>
+              </a:rPr>
+              <a:t>标出重点乡镇最明显的四力短板</a:t>
+            </a:r>
+          </a:p>
+          <a:p>
+            <a:pPr>
+              <a:lnSpc>
+                <a:spcPct val="140000"/>
+              </a:lnSpc>
+            </a:pPr>
+            <a:r>
+              <a:rPr lang="en-US" altLang="zh-CN" sz="1400">
+                <a:solidFill>
+                  <a:srgbClr val="172A3A"/>
+                </a:solidFill>
+                <a:latin typeface="Microsoft YaHei" panose="020B0503020204020204" pitchFamily="34" charset="-122"/>
+                <a:ea typeface="Microsoft YaHei" panose="020B0503020204020204" pitchFamily="34" charset="-122"/>
+              </a:rPr>
+              <a:t>4. </a:t>
+            </a:r>
+            <a:r>
+              <a:rPr lang="zh-CN" altLang="en-US" sz="1400">
+                <a:solidFill>
+                  <a:srgbClr val="172A3A"/>
+                </a:solidFill>
+                <a:latin typeface="Microsoft YaHei" panose="020B0503020204020204" pitchFamily="34" charset="-122"/>
+                <a:ea typeface="Microsoft YaHei" panose="020B0503020204020204" pitchFamily="34" charset="-122"/>
+              </a:rPr>
+              <a:t>初步区分需要继续深耕和需要进一步评估的乡镇</a:t>
+            </a:r>
+          </a:p>
+          <a:p>
+            <a:pPr>
+              <a:lnSpc>
+                <a:spcPct val="140000"/>
+              </a:lnSpc>
+            </a:pPr>
+            <a:r>
+              <a:rPr lang="en-US" altLang="zh-CN" sz="1400">
+                <a:solidFill>
+                  <a:srgbClr val="172A3A"/>
+                </a:solidFill>
+                <a:latin typeface="Microsoft YaHei" panose="020B0503020204020204" pitchFamily="34" charset="-122"/>
+                <a:ea typeface="Microsoft YaHei" panose="020B0503020204020204" pitchFamily="34" charset="-122"/>
+              </a:rPr>
+              <a:t>5. </a:t>
+            </a:r>
+            <a:r>
+              <a:rPr lang="zh-CN" altLang="en-US" sz="1400">
+                <a:solidFill>
+                  <a:srgbClr val="172A3A"/>
+                </a:solidFill>
+                <a:latin typeface="Microsoft YaHei" panose="020B0503020204020204" pitchFamily="34" charset="-122"/>
+                <a:ea typeface="Microsoft YaHei" panose="020B0503020204020204" pitchFamily="34" charset="-122"/>
+              </a:rPr>
+              <a:t>由经销商与雨虹县长课后共同补充真实信息</a:t>
+            </a:r>
+          </a:p>
+        </p:txBody>
+      </p:sp>
+      <p:sp>
+        <p:nvSpPr>
+          <p:cNvPr id="5" name="文本框 4">
+            <a:extLst>
+              <a:ext uri="{FF2B5EF4-FFF2-40B4-BE49-F238E27FC236}">
+                <a16:creationId xmlns:a16="http://schemas.microsoft.com/office/drawing/2014/main" id="{8884B3DF-97C5-4B37-0CE6-228198DEC3F1}"/>
+              </a:ext>
+            </a:extLst>
+          </p:cNvPr>
+          <p:cNvSpPr txBox="1"/>
+          <p:nvPr/>
+        </p:nvSpPr>
+        <p:spPr>
+          <a:xfrm>
+            <a:off x="7223760" y="1463040"/>
+            <a:ext cx="4480560" cy="369332"/>
+          </a:xfrm>
+          <a:prstGeom prst="rect">
+            <a:avLst/>
+          </a:prstGeom>
+          <a:noFill/>
+        </p:spPr>
+        <p:txBody>
+          <a:bodyPr vert="horz" wrap="square" rtlCol="0">
+            <a:noAutofit/>
+          </a:bodyPr>
+          <a:lstStyle/>
+          <a:p>
+            <a:r>
+              <a:rPr lang="zh-CN" altLang="en-US" sz="1300" b="1">
+                <a:solidFill>
+                  <a:srgbClr val="C61720"/>
+                </a:solidFill>
+                <a:latin typeface="Microsoft YaHei" panose="020B0503020204020204" pitchFamily="34" charset="-122"/>
+                <a:ea typeface="Microsoft YaHei" panose="020B0503020204020204" pitchFamily="34" charset="-122"/>
+              </a:rPr>
+              <a:t>示例（匿名化综合案例，仅说明填法）</a:t>
+            </a:r>
+          </a:p>
+        </p:txBody>
+      </p:sp>
+      <p:sp>
+        <p:nvSpPr>
+          <p:cNvPr id="6" name="文本框 5">
+            <a:extLst>
+              <a:ext uri="{FF2B5EF4-FFF2-40B4-BE49-F238E27FC236}">
+                <a16:creationId xmlns:a16="http://schemas.microsoft.com/office/drawing/2014/main" id="{957296A3-8913-6E98-BD3D-D5514D4D3C23}"/>
+              </a:ext>
+            </a:extLst>
+          </p:cNvPr>
+          <p:cNvSpPr txBox="1"/>
+          <p:nvPr/>
+        </p:nvSpPr>
+        <p:spPr>
+          <a:xfrm>
+            <a:off x="7223760" y="2057400"/>
+            <a:ext cx="4480560" cy="369332"/>
+          </a:xfrm>
+          <a:prstGeom prst="rect">
+            <a:avLst/>
+          </a:prstGeom>
+          <a:noFill/>
+        </p:spPr>
+        <p:txBody>
+          <a:bodyPr vert="horz" wrap="square" rtlCol="0">
+            <a:noAutofit/>
+          </a:bodyPr>
+          <a:lstStyle/>
+          <a:p>
+            <a:pPr>
+              <a:lnSpc>
+                <a:spcPct val="130000"/>
+              </a:lnSpc>
+            </a:pPr>
+            <a:r>
+              <a:rPr lang="zh-CN" altLang="en-US" sz="1200">
+                <a:solidFill>
+                  <a:srgbClr val="66747C"/>
+                </a:solidFill>
+                <a:latin typeface="Microsoft YaHei" panose="020B0503020204020204" pitchFamily="34" charset="-122"/>
+                <a:ea typeface="Microsoft YaHei" panose="020B0503020204020204" pitchFamily="34" charset="-122"/>
+              </a:rPr>
+              <a:t>某县经销商早期在多个乡镇平均跑动、广撒网点，后来把资源集中到机场周边两个重点乡镇：县城做仓储配送和品牌展示，两个重点镇各建一个核心网点连接工人和包工头，乡镇业务占比达到六成以上，实现从「乡镇都去过」到「重点乡镇做透」的转变。</a:t>
+            </a:r>
+          </a:p>
+        </p:txBody>
+      </p:sp>
+      <p:sp>
+        <p:nvSpPr>
+          <p:cNvPr id="7" name="文本框 6">
+            <a:extLst>
+              <a:ext uri="{FF2B5EF4-FFF2-40B4-BE49-F238E27FC236}">
+                <a16:creationId xmlns:a16="http://schemas.microsoft.com/office/drawing/2014/main" id="{273754AF-06C4-98B5-CF25-A4ACAE91DFD9}"/>
+              </a:ext>
+            </a:extLst>
+          </p:cNvPr>
+          <p:cNvSpPr txBox="1"/>
+          <p:nvPr/>
+        </p:nvSpPr>
+        <p:spPr>
+          <a:xfrm>
+            <a:off x="640080" y="5943600"/>
+            <a:ext cx="10881360" cy="369332"/>
+          </a:xfrm>
+          <a:prstGeom prst="rect">
+            <a:avLst/>
+          </a:prstGeom>
+          <a:noFill/>
+        </p:spPr>
+        <p:txBody>
+          <a:bodyPr vert="horz" wrap="square" rtlCol="0">
+            <a:noAutofit/>
+          </a:bodyPr>
+          <a:lstStyle/>
+          <a:p>
+            <a:pPr algn="ctr"/>
+            <a:r>
+              <a:rPr lang="zh-CN" altLang="en-US" sz="1500" b="1">
+                <a:solidFill>
+                  <a:srgbClr val="C61720"/>
+                </a:solidFill>
+                <a:latin typeface="Microsoft YaHei" panose="020B0503020204020204" pitchFamily="34" charset="-122"/>
+                <a:ea typeface="Microsoft YaHei" panose="020B0503020204020204" pitchFamily="34" charset="-122"/>
+              </a:rPr>
+              <a:t>这张版图是下一步「盘区域」的输入：判状态看现状，盘区域看外部机会，做完才能决定资源投到哪里。</a:t>
+            </a:r>
+          </a:p>
+        </p:txBody>
+      </p:sp>
+    </p:spTree>
+    <p:extLst>
+      <p:ext uri="{BB962C8B-B14F-4D97-AF65-F5344CB8AC3E}">
+        <p14:creationId xmlns:p14="http://schemas.microsoft.com/office/powerpoint/2010/main" val="940378549"/>
+      </p:ext>
+    </p:extLst>
+  </p:cSld>
+  <p:clrMapOvr>
+    <a:masterClrMapping/>
+  </p:clrMapOvr>
+</p:sld>
+</file>
+
+<file path=ppt/slides/slide15.xml><?xml version="1.0" encoding="utf-8"?>
+<p:sld xmlns:a="http://schemas.openxmlformats.org/drawingml/2006/main" xmlns:r="http://schemas.openxmlformats.org/officeDocument/2006/relationships" xmlns:p="http://schemas.openxmlformats.org/presentationml/2006/main">
+  <p:cSld>
+    <p:spTree>
+      <p:nvGrpSpPr>
+        <p:cNvPr id="1" name=""/>
+        <p:cNvGrpSpPr/>
+        <p:nvPr/>
+      </p:nvGrpSpPr>
+      <p:grpSpPr>
+        <a:xfrm>
+          <a:off x="0" y="0"/>
+          <a:ext cx="0" cy="0"/>
+          <a:chOff x="0" y="0"/>
+          <a:chExt cx="0" cy="0"/>
+        </a:xfrm>
+      </p:grpSpPr>
+      <p:sp>
+        <p:nvSpPr>
+          <p:cNvPr id="2" name="文本框 1">
+            <a:extLst>
+              <a:ext uri="{FF2B5EF4-FFF2-40B4-BE49-F238E27FC236}">
+                <a16:creationId xmlns:a16="http://schemas.microsoft.com/office/drawing/2014/main" id="{51C54961-1B7B-EB4C-2984-32E39EDAB253}"/>
               </a:ext>
             </a:extLst>
           </p:cNvPr>
@@ -8429,7 +10333,7 @@
           <p:cNvPr id="3" name="文本框 2">
             <a:extLst>
               <a:ext uri="{FF2B5EF4-FFF2-40B4-BE49-F238E27FC236}">
-                <a16:creationId xmlns:a16="http://schemas.microsoft.com/office/drawing/2014/main" id="{E3A97FFD-4FC3-0E9D-98E6-35930A51ED46}"/>
+                <a16:creationId xmlns:a16="http://schemas.microsoft.com/office/drawing/2014/main" id="{B3B4CA68-5CC2-DA18-E0E5-8FFC8F5EE570}"/>
               </a:ext>
             </a:extLst>
           </p:cNvPr>
@@ -8475,7 +10379,7 @@
           <p:cNvPr id="4" name="文本框 3">
             <a:extLst>
               <a:ext uri="{FF2B5EF4-FFF2-40B4-BE49-F238E27FC236}">
-                <a16:creationId xmlns:a16="http://schemas.microsoft.com/office/drawing/2014/main" id="{D7F04DE2-754E-0776-6DB8-57ADEF6A67F5}"/>
+                <a16:creationId xmlns:a16="http://schemas.microsoft.com/office/drawing/2014/main" id="{351FEE47-A16F-6A14-21A5-3F7B173763CD}"/>
               </a:ext>
             </a:extLst>
           </p:cNvPr>
@@ -8517,7 +10421,7 @@
           <p:cNvPr id="5" name="文本框 4">
             <a:extLst>
               <a:ext uri="{FF2B5EF4-FFF2-40B4-BE49-F238E27FC236}">
-                <a16:creationId xmlns:a16="http://schemas.microsoft.com/office/drawing/2014/main" id="{5CDC2F74-0673-9FFD-0F37-F10D6BC368F1}"/>
+                <a16:creationId xmlns:a16="http://schemas.microsoft.com/office/drawing/2014/main" id="{01343149-D25A-8326-698F-7BF0C82E8D69}"/>
               </a:ext>
             </a:extLst>
           </p:cNvPr>
@@ -8601,7 +10505,7 @@
     </p:spTree>
     <p:extLst>
       <p:ext uri="{BB962C8B-B14F-4D97-AF65-F5344CB8AC3E}">
-        <p14:creationId xmlns:p14="http://schemas.microsoft.com/office/powerpoint/2010/main" val="2952015304"/>
+        <p14:creationId xmlns:p14="http://schemas.microsoft.com/office/powerpoint/2010/main" val="976224304"/>
       </p:ext>
     </p:extLst>
   </p:cSld>
@@ -8633,7 +10537,7 @@
           <p:cNvPr id="2" name="文本框 1">
             <a:extLst>
               <a:ext uri="{FF2B5EF4-FFF2-40B4-BE49-F238E27FC236}">
-                <a16:creationId xmlns:a16="http://schemas.microsoft.com/office/drawing/2014/main" id="{44F91510-B345-B068-826D-32D36550159E}"/>
+                <a16:creationId xmlns:a16="http://schemas.microsoft.com/office/drawing/2014/main" id="{4DB4F26D-3448-52E9-964A-FAFF284A765A}"/>
               </a:ext>
             </a:extLst>
           </p:cNvPr>
@@ -8674,7 +10578,7 @@
           <p:cNvPr id="3" name="文本框 2">
             <a:extLst>
               <a:ext uri="{FF2B5EF4-FFF2-40B4-BE49-F238E27FC236}">
-                <a16:creationId xmlns:a16="http://schemas.microsoft.com/office/drawing/2014/main" id="{F2F93C48-EC54-4E6E-61A4-4518A4A3B874}"/>
+                <a16:creationId xmlns:a16="http://schemas.microsoft.com/office/drawing/2014/main" id="{BDC8BFD4-5451-A102-01ED-2C38803AA887}"/>
               </a:ext>
             </a:extLst>
           </p:cNvPr>
@@ -8720,7 +10624,7 @@
           <p:cNvPr id="4" name="文本框 3">
             <a:extLst>
               <a:ext uri="{FF2B5EF4-FFF2-40B4-BE49-F238E27FC236}">
-                <a16:creationId xmlns:a16="http://schemas.microsoft.com/office/drawing/2014/main" id="{9D3656E1-1AD0-B78B-0232-973666CA3D51}"/>
+                <a16:creationId xmlns:a16="http://schemas.microsoft.com/office/drawing/2014/main" id="{AF3DEB12-4A58-9F62-68F3-4A7ADB3326E2}"/>
               </a:ext>
             </a:extLst>
           </p:cNvPr>
@@ -8775,7 +10679,7 @@
           <p:cNvPr id="5" name="文本框 4">
             <a:extLst>
               <a:ext uri="{FF2B5EF4-FFF2-40B4-BE49-F238E27FC236}">
-                <a16:creationId xmlns:a16="http://schemas.microsoft.com/office/drawing/2014/main" id="{95E0B95E-E833-D5CA-30C6-16A196F0346E}"/>
+                <a16:creationId xmlns:a16="http://schemas.microsoft.com/office/drawing/2014/main" id="{17E53CC3-F23B-5867-48F3-FA286A2F7B4D}"/>
               </a:ext>
             </a:extLst>
           </p:cNvPr>
@@ -8830,7 +10734,7 @@
           <p:cNvPr id="6" name="文本框 5">
             <a:extLst>
               <a:ext uri="{FF2B5EF4-FFF2-40B4-BE49-F238E27FC236}">
-                <a16:creationId xmlns:a16="http://schemas.microsoft.com/office/drawing/2014/main" id="{7E9318A2-BF49-0A1E-F724-0FDA8E900C9D}"/>
+                <a16:creationId xmlns:a16="http://schemas.microsoft.com/office/drawing/2014/main" id="{3CC7C336-0821-1F4D-3808-CE9373656D38}"/>
               </a:ext>
             </a:extLst>
           </p:cNvPr>
@@ -8885,7 +10789,7 @@
           <p:cNvPr id="7" name="文本框 6">
             <a:extLst>
               <a:ext uri="{FF2B5EF4-FFF2-40B4-BE49-F238E27FC236}">
-                <a16:creationId xmlns:a16="http://schemas.microsoft.com/office/drawing/2014/main" id="{F3322A62-9D16-0628-9D00-676B750E08CE}"/>
+                <a16:creationId xmlns:a16="http://schemas.microsoft.com/office/drawing/2014/main" id="{54C008A6-2468-11B0-8B7D-E3C91F3A0818}"/>
               </a:ext>
             </a:extLst>
           </p:cNvPr>
@@ -8925,7 +10829,7 @@
     </p:spTree>
     <p:extLst>
       <p:ext uri="{BB962C8B-B14F-4D97-AF65-F5344CB8AC3E}">
-        <p14:creationId xmlns:p14="http://schemas.microsoft.com/office/powerpoint/2010/main" val="839992923"/>
+        <p14:creationId xmlns:p14="http://schemas.microsoft.com/office/powerpoint/2010/main" val="2330052762"/>
       </p:ext>
     </p:extLst>
   </p:cSld>
@@ -8957,7 +10861,7 @@
           <p:cNvPr id="2" name="文本框 1">
             <a:extLst>
               <a:ext uri="{FF2B5EF4-FFF2-40B4-BE49-F238E27FC236}">
-                <a16:creationId xmlns:a16="http://schemas.microsoft.com/office/drawing/2014/main" id="{974F631C-6990-A84F-7A75-491DDFB394DF}"/>
+                <a16:creationId xmlns:a16="http://schemas.microsoft.com/office/drawing/2014/main" id="{A4EF7E84-D12E-0726-87CD-1FDCCDA5E915}"/>
               </a:ext>
             </a:extLst>
           </p:cNvPr>
@@ -8998,7 +10902,7 @@
           <p:cNvPr id="3" name="文本框 2">
             <a:extLst>
               <a:ext uri="{FF2B5EF4-FFF2-40B4-BE49-F238E27FC236}">
-                <a16:creationId xmlns:a16="http://schemas.microsoft.com/office/drawing/2014/main" id="{B7280B29-B72C-6DEA-1331-1CF4A3F25C13}"/>
+                <a16:creationId xmlns:a16="http://schemas.microsoft.com/office/drawing/2014/main" id="{A597E253-04A2-E46E-7F37-A54DC9A27167}"/>
               </a:ext>
             </a:extLst>
           </p:cNvPr>
@@ -9051,7 +10955,7 @@
           <p:cNvPr id="4" name="文本框 3">
             <a:extLst>
               <a:ext uri="{FF2B5EF4-FFF2-40B4-BE49-F238E27FC236}">
-                <a16:creationId xmlns:a16="http://schemas.microsoft.com/office/drawing/2014/main" id="{8B74EA90-E660-9973-76C5-434B7DC8278F}"/>
+                <a16:creationId xmlns:a16="http://schemas.microsoft.com/office/drawing/2014/main" id="{4699422E-0CCA-43FF-6474-A0E391F4E1FF}"/>
               </a:ext>
             </a:extLst>
           </p:cNvPr>
@@ -9114,7 +11018,7 @@
           <p:cNvPr id="5" name="文本框 4">
             <a:extLst>
               <a:ext uri="{FF2B5EF4-FFF2-40B4-BE49-F238E27FC236}">
-                <a16:creationId xmlns:a16="http://schemas.microsoft.com/office/drawing/2014/main" id="{7D130826-6BD7-D1F8-99B5-37639065008B}"/>
+                <a16:creationId xmlns:a16="http://schemas.microsoft.com/office/drawing/2014/main" id="{79DA130E-D0E8-F7CB-8CDB-1B861DCB6F3B}"/>
               </a:ext>
             </a:extLst>
           </p:cNvPr>
@@ -9167,7 +11071,7 @@
           <p:cNvPr id="6" name="文本框 5">
             <a:extLst>
               <a:ext uri="{FF2B5EF4-FFF2-40B4-BE49-F238E27FC236}">
-                <a16:creationId xmlns:a16="http://schemas.microsoft.com/office/drawing/2014/main" id="{81020103-2731-E835-008D-C1F299897F5F}"/>
+                <a16:creationId xmlns:a16="http://schemas.microsoft.com/office/drawing/2014/main" id="{812A76C0-6B4D-EFB7-E1E3-1EE3DB37B0E4}"/>
               </a:ext>
             </a:extLst>
           </p:cNvPr>
@@ -9230,7 +11134,7 @@
           <p:cNvPr id="7" name="文本框 6">
             <a:extLst>
               <a:ext uri="{FF2B5EF4-FFF2-40B4-BE49-F238E27FC236}">
-                <a16:creationId xmlns:a16="http://schemas.microsoft.com/office/drawing/2014/main" id="{9AB98C52-4C66-52F9-C86E-9796526FA436}"/>
+                <a16:creationId xmlns:a16="http://schemas.microsoft.com/office/drawing/2014/main" id="{DEDF1EEA-32E7-3F15-1D1D-B2A4DA36C4A2}"/>
               </a:ext>
             </a:extLst>
           </p:cNvPr>
@@ -9295,7 +11199,7 @@
           <p:cNvPr id="8" name="文本框 7">
             <a:extLst>
               <a:ext uri="{FF2B5EF4-FFF2-40B4-BE49-F238E27FC236}">
-                <a16:creationId xmlns:a16="http://schemas.microsoft.com/office/drawing/2014/main" id="{A346FA26-E51D-F003-EDDD-AC29DC6BF433}"/>
+                <a16:creationId xmlns:a16="http://schemas.microsoft.com/office/drawing/2014/main" id="{20DB9107-CD45-2EE4-AC8D-3C8F031E825C}"/>
               </a:ext>
             </a:extLst>
           </p:cNvPr>
@@ -9358,7 +11262,7 @@
           <p:cNvPr id="9" name="文本框 8">
             <a:extLst>
               <a:ext uri="{FF2B5EF4-FFF2-40B4-BE49-F238E27FC236}">
-                <a16:creationId xmlns:a16="http://schemas.microsoft.com/office/drawing/2014/main" id="{6AD48B6E-283B-A5D1-BC29-E2BC961F28D4}"/>
+                <a16:creationId xmlns:a16="http://schemas.microsoft.com/office/drawing/2014/main" id="{C838EC6D-2E78-4B0E-2B39-FC2291B50CFB}"/>
               </a:ext>
             </a:extLst>
           </p:cNvPr>
@@ -9398,7 +11302,7 @@
     </p:spTree>
     <p:extLst>
       <p:ext uri="{BB962C8B-B14F-4D97-AF65-F5344CB8AC3E}">
-        <p14:creationId xmlns:p14="http://schemas.microsoft.com/office/powerpoint/2010/main" val="561147855"/>
+        <p14:creationId xmlns:p14="http://schemas.microsoft.com/office/powerpoint/2010/main" val="4101921529"/>
       </p:ext>
     </p:extLst>
   </p:cSld>
@@ -9430,7 +11334,7 @@
           <p:cNvPr id="2" name="文本框 1">
             <a:extLst>
               <a:ext uri="{FF2B5EF4-FFF2-40B4-BE49-F238E27FC236}">
-                <a16:creationId xmlns:a16="http://schemas.microsoft.com/office/drawing/2014/main" id="{AF18B247-D8A0-94C3-7782-14988FE28EDD}"/>
+                <a16:creationId xmlns:a16="http://schemas.microsoft.com/office/drawing/2014/main" id="{527A3823-6BE3-06A8-071E-DFB9CCD0642F}"/>
               </a:ext>
             </a:extLst>
           </p:cNvPr>
@@ -9471,7 +11375,7 @@
           <p:cNvPr id="3" name="文本框 2">
             <a:extLst>
               <a:ext uri="{FF2B5EF4-FFF2-40B4-BE49-F238E27FC236}">
-                <a16:creationId xmlns:a16="http://schemas.microsoft.com/office/drawing/2014/main" id="{69FA84DF-045F-C8DF-6555-6D07DD466276}"/>
+                <a16:creationId xmlns:a16="http://schemas.microsoft.com/office/drawing/2014/main" id="{3AE3E3B3-E064-9E5C-1043-54130E40BF88}"/>
               </a:ext>
             </a:extLst>
           </p:cNvPr>
@@ -9512,7 +11416,7 @@
           <p:cNvPr id="4" name="文本框 3">
             <a:extLst>
               <a:ext uri="{FF2B5EF4-FFF2-40B4-BE49-F238E27FC236}">
-                <a16:creationId xmlns:a16="http://schemas.microsoft.com/office/drawing/2014/main" id="{385AEBD0-A13A-F714-E393-E53E839B90EA}"/>
+                <a16:creationId xmlns:a16="http://schemas.microsoft.com/office/drawing/2014/main" id="{91492540-4527-57D3-B75D-6B97F266762C}"/>
               </a:ext>
             </a:extLst>
           </p:cNvPr>
@@ -9553,7 +11457,7 @@
           <p:cNvPr id="5" name="文本框 4">
             <a:extLst>
               <a:ext uri="{FF2B5EF4-FFF2-40B4-BE49-F238E27FC236}">
-                <a16:creationId xmlns:a16="http://schemas.microsoft.com/office/drawing/2014/main" id="{74328E93-BAAE-9685-0D88-EFFB50124FA7}"/>
+                <a16:creationId xmlns:a16="http://schemas.microsoft.com/office/drawing/2014/main" id="{36194756-1668-043E-1656-07949A96377C}"/>
               </a:ext>
             </a:extLst>
           </p:cNvPr>
@@ -9594,7 +11498,7 @@
           <p:cNvPr id="6" name="文本框 5">
             <a:extLst>
               <a:ext uri="{FF2B5EF4-FFF2-40B4-BE49-F238E27FC236}">
-                <a16:creationId xmlns:a16="http://schemas.microsoft.com/office/drawing/2014/main" id="{E6F89E07-5035-2E1D-BEA2-D698E40E1499}"/>
+                <a16:creationId xmlns:a16="http://schemas.microsoft.com/office/drawing/2014/main" id="{4EFA1C79-FDBE-B39E-8CEA-CA2F4A219DE6}"/>
               </a:ext>
             </a:extLst>
           </p:cNvPr>
@@ -9635,7 +11539,7 @@
           <p:cNvPr id="7" name="文本框 6">
             <a:extLst>
               <a:ext uri="{FF2B5EF4-FFF2-40B4-BE49-F238E27FC236}">
-                <a16:creationId xmlns:a16="http://schemas.microsoft.com/office/drawing/2014/main" id="{8917DCE9-F60C-588F-2AFC-9522AEDA7611}"/>
+                <a16:creationId xmlns:a16="http://schemas.microsoft.com/office/drawing/2014/main" id="{72FF9B06-8724-88C3-51CE-C4AFBABF67A1}"/>
               </a:ext>
             </a:extLst>
           </p:cNvPr>
@@ -9676,7 +11580,7 @@
           <p:cNvPr id="8" name="文本框 7">
             <a:extLst>
               <a:ext uri="{FF2B5EF4-FFF2-40B4-BE49-F238E27FC236}">
-                <a16:creationId xmlns:a16="http://schemas.microsoft.com/office/drawing/2014/main" id="{941C6FAC-935C-8E46-F9F1-299030ECA151}"/>
+                <a16:creationId xmlns:a16="http://schemas.microsoft.com/office/drawing/2014/main" id="{7F9C6F5D-5F4A-FF1B-3492-FA55681DB6E2}"/>
               </a:ext>
             </a:extLst>
           </p:cNvPr>
@@ -9717,7 +11621,7 @@
           <p:cNvPr id="9" name="文本框 8">
             <a:extLst>
               <a:ext uri="{FF2B5EF4-FFF2-40B4-BE49-F238E27FC236}">
-                <a16:creationId xmlns:a16="http://schemas.microsoft.com/office/drawing/2014/main" id="{8FAF791C-22A6-8D9F-D6BD-6D47E57AB744}"/>
+                <a16:creationId xmlns:a16="http://schemas.microsoft.com/office/drawing/2014/main" id="{11543BAA-F04C-96EF-45A2-1776FB7FAC06}"/>
               </a:ext>
             </a:extLst>
           </p:cNvPr>
@@ -9758,7 +11662,7 @@
           <p:cNvPr id="10" name="文本框 9">
             <a:extLst>
               <a:ext uri="{FF2B5EF4-FFF2-40B4-BE49-F238E27FC236}">
-                <a16:creationId xmlns:a16="http://schemas.microsoft.com/office/drawing/2014/main" id="{A5B69142-3C8D-25BD-FB99-ECD5E3AB5C78}"/>
+                <a16:creationId xmlns:a16="http://schemas.microsoft.com/office/drawing/2014/main" id="{4040E375-6077-1265-DF12-E055BD88AF02}"/>
               </a:ext>
             </a:extLst>
           </p:cNvPr>
@@ -9799,7 +11703,7 @@
           <p:cNvPr id="11" name="文本框 10">
             <a:extLst>
               <a:ext uri="{FF2B5EF4-FFF2-40B4-BE49-F238E27FC236}">
-                <a16:creationId xmlns:a16="http://schemas.microsoft.com/office/drawing/2014/main" id="{D284997D-6E24-68E4-7853-B950A00F7F6F}"/>
+                <a16:creationId xmlns:a16="http://schemas.microsoft.com/office/drawing/2014/main" id="{928AC112-8B14-C757-39E7-2865859AA9F6}"/>
               </a:ext>
             </a:extLst>
           </p:cNvPr>
@@ -9843,7 +11747,7 @@
     </p:spTree>
     <p:extLst>
       <p:ext uri="{BB962C8B-B14F-4D97-AF65-F5344CB8AC3E}">
-        <p14:creationId xmlns:p14="http://schemas.microsoft.com/office/powerpoint/2010/main" val="2838931721"/>
+        <p14:creationId xmlns:p14="http://schemas.microsoft.com/office/powerpoint/2010/main" val="2809682258"/>
       </p:ext>
     </p:extLst>
   </p:cSld>
@@ -9875,7 +11779,7 @@
           <p:cNvPr id="2" name="文本框 1">
             <a:extLst>
               <a:ext uri="{FF2B5EF4-FFF2-40B4-BE49-F238E27FC236}">
-                <a16:creationId xmlns:a16="http://schemas.microsoft.com/office/drawing/2014/main" id="{14F2A953-FD53-7ACE-28A7-420E368BAD62}"/>
+                <a16:creationId xmlns:a16="http://schemas.microsoft.com/office/drawing/2014/main" id="{0F94D264-8E03-3A56-501D-3E2410E5DB20}"/>
               </a:ext>
             </a:extLst>
           </p:cNvPr>
@@ -9916,7 +11820,7 @@
           <p:cNvPr id="3" name="文本框 2">
             <a:extLst>
               <a:ext uri="{FF2B5EF4-FFF2-40B4-BE49-F238E27FC236}">
-                <a16:creationId xmlns:a16="http://schemas.microsoft.com/office/drawing/2014/main" id="{317FB9E5-1092-B06F-7F62-0349DAB4C1B9}"/>
+                <a16:creationId xmlns:a16="http://schemas.microsoft.com/office/drawing/2014/main" id="{B4A0BB5E-C60F-2292-9F14-72568D7DBB10}"/>
               </a:ext>
             </a:extLst>
           </p:cNvPr>
@@ -9977,7 +11881,7 @@
           <p:cNvPr id="4" name="文本框 3">
             <a:extLst>
               <a:ext uri="{FF2B5EF4-FFF2-40B4-BE49-F238E27FC236}">
-                <a16:creationId xmlns:a16="http://schemas.microsoft.com/office/drawing/2014/main" id="{A5C248B1-0E43-8F95-0E4B-06354AF206E7}"/>
+                <a16:creationId xmlns:a16="http://schemas.microsoft.com/office/drawing/2014/main" id="{2F80006D-C2BD-0217-7451-F3F4949D74F0}"/>
               </a:ext>
             </a:extLst>
           </p:cNvPr>
@@ -10091,7 +11995,7 @@
           <p:cNvPr id="5" name="文本框 4">
             <a:extLst>
               <a:ext uri="{FF2B5EF4-FFF2-40B4-BE49-F238E27FC236}">
-                <a16:creationId xmlns:a16="http://schemas.microsoft.com/office/drawing/2014/main" id="{78F00F83-C0B0-6338-861C-FFF224819EE6}"/>
+                <a16:creationId xmlns:a16="http://schemas.microsoft.com/office/drawing/2014/main" id="{74880818-FD0B-2DFA-C3AC-22A35218B143}"/>
               </a:ext>
             </a:extLst>
           </p:cNvPr>
@@ -10152,7 +12056,7 @@
           <p:cNvPr id="6" name="文本框 5">
             <a:extLst>
               <a:ext uri="{FF2B5EF4-FFF2-40B4-BE49-F238E27FC236}">
-                <a16:creationId xmlns:a16="http://schemas.microsoft.com/office/drawing/2014/main" id="{7BC0877D-174B-BD07-9056-B13B5BA19C7B}"/>
+                <a16:creationId xmlns:a16="http://schemas.microsoft.com/office/drawing/2014/main" id="{F60F8345-85D5-4428-1354-13FA29DECEBE}"/>
               </a:ext>
             </a:extLst>
           </p:cNvPr>
@@ -10266,7 +12170,7 @@
           <p:cNvPr id="7" name="文本框 6">
             <a:extLst>
               <a:ext uri="{FF2B5EF4-FFF2-40B4-BE49-F238E27FC236}">
-                <a16:creationId xmlns:a16="http://schemas.microsoft.com/office/drawing/2014/main" id="{489D004B-448E-00AA-962E-112D9648058A}"/>
+                <a16:creationId xmlns:a16="http://schemas.microsoft.com/office/drawing/2014/main" id="{4F5EF88F-AF58-3C77-9B69-602F6300E5FF}"/>
               </a:ext>
             </a:extLst>
           </p:cNvPr>
@@ -10327,7 +12231,7 @@
           <p:cNvPr id="8" name="文本框 7">
             <a:extLst>
               <a:ext uri="{FF2B5EF4-FFF2-40B4-BE49-F238E27FC236}">
-                <a16:creationId xmlns:a16="http://schemas.microsoft.com/office/drawing/2014/main" id="{2E5722CB-0D6A-6AA5-D443-35FE4F15127D}"/>
+                <a16:creationId xmlns:a16="http://schemas.microsoft.com/office/drawing/2014/main" id="{6A8538E0-0F18-4050-173B-3B23BF8557CA}"/>
               </a:ext>
             </a:extLst>
           </p:cNvPr>
@@ -10424,7 +12328,7 @@
           <p:cNvPr id="9" name="文本框 8">
             <a:extLst>
               <a:ext uri="{FF2B5EF4-FFF2-40B4-BE49-F238E27FC236}">
-                <a16:creationId xmlns:a16="http://schemas.microsoft.com/office/drawing/2014/main" id="{C2C4C188-D6AF-EE2C-90CE-8CEE77292569}"/>
+                <a16:creationId xmlns:a16="http://schemas.microsoft.com/office/drawing/2014/main" id="{D5123D4F-D049-6B73-2C62-79ACEC1E6BEC}"/>
               </a:ext>
             </a:extLst>
           </p:cNvPr>
@@ -10488,7 +12392,7 @@
     </p:spTree>
     <p:extLst>
       <p:ext uri="{BB962C8B-B14F-4D97-AF65-F5344CB8AC3E}">
-        <p14:creationId xmlns:p14="http://schemas.microsoft.com/office/powerpoint/2010/main" val="3721839125"/>
+        <p14:creationId xmlns:p14="http://schemas.microsoft.com/office/powerpoint/2010/main" val="3181815375"/>
       </p:ext>
     </p:extLst>
   </p:cSld>
@@ -10520,7 +12424,7 @@
           <p:cNvPr id="2" name="文本框 1">
             <a:extLst>
               <a:ext uri="{FF2B5EF4-FFF2-40B4-BE49-F238E27FC236}">
-                <a16:creationId xmlns:a16="http://schemas.microsoft.com/office/drawing/2014/main" id="{4E48CA80-9E56-C935-93F6-60EA81F0606A}"/>
+                <a16:creationId xmlns:a16="http://schemas.microsoft.com/office/drawing/2014/main" id="{6C91CD36-F79E-AB48-271B-AD10BA6F74CC}"/>
               </a:ext>
             </a:extLst>
           </p:cNvPr>
@@ -10561,7 +12465,7 @@
           <p:cNvPr id="3" name="文本框 2">
             <a:extLst>
               <a:ext uri="{FF2B5EF4-FFF2-40B4-BE49-F238E27FC236}">
-                <a16:creationId xmlns:a16="http://schemas.microsoft.com/office/drawing/2014/main" id="{6C18C983-025F-36D4-7052-BBA0D374920F}"/>
+                <a16:creationId xmlns:a16="http://schemas.microsoft.com/office/drawing/2014/main" id="{D274A40C-03BE-1B6E-791C-217E75F918C9}"/>
               </a:ext>
             </a:extLst>
           </p:cNvPr>
@@ -10602,7 +12506,7 @@
           <p:cNvPr id="4" name="文本框 3">
             <a:extLst>
               <a:ext uri="{FF2B5EF4-FFF2-40B4-BE49-F238E27FC236}">
-                <a16:creationId xmlns:a16="http://schemas.microsoft.com/office/drawing/2014/main" id="{B33E7597-DCC8-1650-987C-A66D069127DA}"/>
+                <a16:creationId xmlns:a16="http://schemas.microsoft.com/office/drawing/2014/main" id="{FAE523F3-D0F8-4C2E-BE90-28F8EAC360ED}"/>
               </a:ext>
             </a:extLst>
           </p:cNvPr>
@@ -10716,7 +12620,7 @@
           <p:cNvPr id="5" name="文本框 4">
             <a:extLst>
               <a:ext uri="{FF2B5EF4-FFF2-40B4-BE49-F238E27FC236}">
-                <a16:creationId xmlns:a16="http://schemas.microsoft.com/office/drawing/2014/main" id="{9C2A4CC1-AAF3-0772-2926-B51B6F6873F8}"/>
+                <a16:creationId xmlns:a16="http://schemas.microsoft.com/office/drawing/2014/main" id="{F5296AA9-97E5-9BEA-C5D9-0880F873E030}"/>
               </a:ext>
             </a:extLst>
           </p:cNvPr>
@@ -10757,7 +12661,7 @@
           <p:cNvPr id="6" name="文本框 5">
             <a:extLst>
               <a:ext uri="{FF2B5EF4-FFF2-40B4-BE49-F238E27FC236}">
-                <a16:creationId xmlns:a16="http://schemas.microsoft.com/office/drawing/2014/main" id="{EF8D5560-4F79-1581-642F-C517E9FD2824}"/>
+                <a16:creationId xmlns:a16="http://schemas.microsoft.com/office/drawing/2014/main" id="{24583E23-2952-3937-351D-1F8D413A0429}"/>
               </a:ext>
             </a:extLst>
           </p:cNvPr>
@@ -10871,7 +12775,7 @@
           <p:cNvPr id="7" name="文本框 6">
             <a:extLst>
               <a:ext uri="{FF2B5EF4-FFF2-40B4-BE49-F238E27FC236}">
-                <a16:creationId xmlns:a16="http://schemas.microsoft.com/office/drawing/2014/main" id="{85E1A625-65CD-887B-B991-C0C4D60C132A}"/>
+                <a16:creationId xmlns:a16="http://schemas.microsoft.com/office/drawing/2014/main" id="{3398B376-C08B-2D0C-2E64-6D39B32ED735}"/>
               </a:ext>
             </a:extLst>
           </p:cNvPr>
@@ -10935,7 +12839,7 @@
     </p:spTree>
     <p:extLst>
       <p:ext uri="{BB962C8B-B14F-4D97-AF65-F5344CB8AC3E}">
-        <p14:creationId xmlns:p14="http://schemas.microsoft.com/office/powerpoint/2010/main" val="251835236"/>
+        <p14:creationId xmlns:p14="http://schemas.microsoft.com/office/powerpoint/2010/main" val="1919444452"/>
       </p:ext>
     </p:extLst>
   </p:cSld>

</xml_diff>